<commit_message>
final version Summer 2025
</commit_message>
<xml_diff>
--- a/Lecture_Slides/PH 123 Lecture 35.pptx
+++ b/Lecture_Slides/PH 123 Lecture 35.pptx
@@ -4,6 +4,9 @@
   <p:sldMasterIdLst>
     <p:sldMasterId id="2147483648" r:id="rId1"/>
   </p:sldMasterIdLst>
+  <p:notesMasterIdLst>
+    <p:notesMasterId r:id="rId49"/>
+  </p:notesMasterIdLst>
   <p:sldIdLst>
     <p:sldId id="281" r:id="rId2"/>
     <p:sldId id="485" r:id="rId3"/>
@@ -172,7 +175,7 @@
 <file path=ppt/revisionInfo.xml><?xml version="1.0" encoding="utf-8"?>
 <p1510:revInfo xmlns:a="http://schemas.openxmlformats.org/drawingml/2006/main" xmlns:r="http://schemas.openxmlformats.org/officeDocument/2006/relationships" xmlns:p1510="http://schemas.microsoft.com/office/powerpoint/2015/10/main">
   <p1510:revLst>
-    <p1510:client id="{002822DB-EE53-4F2A-8F03-1C9D4C4542CA}" v="28" dt="2025-07-08T19:20:59.460"/>
+    <p1510:client id="{002822DB-EE53-4F2A-8F03-1C9D4C4542CA}" v="38" dt="2025-07-18T17:51:42.576"/>
   </p1510:revLst>
 </p1510:revInfo>
 </file>
@@ -182,7 +185,7 @@
   <pc:docChgLst>
     <pc:chgData name="Lines, Todd" userId="afaf7c3a-e8aa-4568-882a-02ad8f9e19b0" providerId="ADAL" clId="{002822DB-EE53-4F2A-8F03-1C9D4C4542CA}"/>
     <pc:docChg chg="custSel addSld delSld modSld sldOrd">
-      <pc:chgData name="Lines, Todd" userId="afaf7c3a-e8aa-4568-882a-02ad8f9e19b0" providerId="ADAL" clId="{002822DB-EE53-4F2A-8F03-1C9D4C4542CA}" dt="2025-07-08T19:35:40.494" v="594" actId="1035"/>
+      <pc:chgData name="Lines, Todd" userId="afaf7c3a-e8aa-4568-882a-02ad8f9e19b0" providerId="ADAL" clId="{002822DB-EE53-4F2A-8F03-1C9D4C4542CA}" dt="2025-07-18T17:51:46.494" v="641" actId="21"/>
       <pc:docMkLst>
         <pc:docMk/>
       </pc:docMkLst>
@@ -237,14 +240,6 @@
           <pc:docMk/>
           <pc:sldMk cId="2610071715" sldId="284"/>
         </pc:sldMkLst>
-        <pc:picChg chg="del mod">
-          <ac:chgData name="Lines, Todd" userId="afaf7c3a-e8aa-4568-882a-02ad8f9e19b0" providerId="ADAL" clId="{002822DB-EE53-4F2A-8F03-1C9D4C4542CA}" dt="2025-07-08T19:12:43.486" v="565" actId="21"/>
-          <ac:picMkLst>
-            <pc:docMk/>
-            <pc:sldMk cId="2610071715" sldId="284"/>
-            <ac:picMk id="3" creationId="{3BA3EF61-268C-E181-70C3-B1C41F415E5D}"/>
-          </ac:picMkLst>
-        </pc:picChg>
         <pc:picChg chg="add mod">
           <ac:chgData name="Lines, Todd" userId="afaf7c3a-e8aa-4568-882a-02ad8f9e19b0" providerId="ADAL" clId="{002822DB-EE53-4F2A-8F03-1C9D4C4542CA}" dt="2025-07-03T22:34:54.038" v="27" actId="1076"/>
           <ac:picMkLst>
@@ -284,17 +279,17 @@
         </pc:sldMkLst>
       </pc:sldChg>
       <pc:sldChg chg="addSp delSp modSp new mod">
-        <pc:chgData name="Lines, Todd" userId="afaf7c3a-e8aa-4568-882a-02ad8f9e19b0" providerId="ADAL" clId="{002822DB-EE53-4F2A-8F03-1C9D4C4542CA}" dt="2025-07-08T19:15:22.834" v="574" actId="21"/>
+        <pc:chgData name="Lines, Todd" userId="afaf7c3a-e8aa-4568-882a-02ad8f9e19b0" providerId="ADAL" clId="{002822DB-EE53-4F2A-8F03-1C9D4C4542CA}" dt="2025-07-18T17:45:09.371" v="601" actId="21"/>
         <pc:sldMkLst>
           <pc:docMk/>
           <pc:sldMk cId="975446107" sldId="466"/>
         </pc:sldMkLst>
         <pc:picChg chg="del mod">
-          <ac:chgData name="Lines, Todd" userId="afaf7c3a-e8aa-4568-882a-02ad8f9e19b0" providerId="ADAL" clId="{002822DB-EE53-4F2A-8F03-1C9D4C4542CA}" dt="2025-07-08T19:15:22.834" v="574" actId="21"/>
+          <ac:chgData name="Lines, Todd" userId="afaf7c3a-e8aa-4568-882a-02ad8f9e19b0" providerId="ADAL" clId="{002822DB-EE53-4F2A-8F03-1C9D4C4542CA}" dt="2025-07-18T17:45:09.371" v="601" actId="21"/>
           <ac:picMkLst>
             <pc:docMk/>
             <pc:sldMk cId="975446107" sldId="466"/>
-            <ac:picMk id="3" creationId="{82303840-8BE9-36DF-9236-E3520FFAF485}"/>
+            <ac:picMk id="5" creationId="{2DE00E35-56C9-A012-58D0-D2C3711FCD96}"/>
           </ac:picMkLst>
         </pc:picChg>
         <pc:picChg chg="add mod">
@@ -306,11 +301,19 @@
           </ac:picMkLst>
         </pc:picChg>
         <pc:cxnChg chg="add mod">
-          <ac:chgData name="Lines, Todd" userId="afaf7c3a-e8aa-4568-882a-02ad8f9e19b0" providerId="ADAL" clId="{002822DB-EE53-4F2A-8F03-1C9D4C4542CA}" dt="2025-07-08T19:15:01.326" v="566"/>
+          <ac:chgData name="Lines, Todd" userId="afaf7c3a-e8aa-4568-882a-02ad8f9e19b0" providerId="ADAL" clId="{002822DB-EE53-4F2A-8F03-1C9D4C4542CA}" dt="2025-07-18T17:44:53.901" v="599" actId="692"/>
           <ac:cxnSpMkLst>
             <pc:docMk/>
             <pc:sldMk cId="975446107" sldId="466"/>
             <ac:cxnSpMk id="2" creationId="{0D1BAB16-90DD-3275-B8BF-0A11B1D71F90}"/>
+          </ac:cxnSpMkLst>
+        </pc:cxnChg>
+        <pc:cxnChg chg="add mod">
+          <ac:chgData name="Lines, Todd" userId="afaf7c3a-e8aa-4568-882a-02ad8f9e19b0" providerId="ADAL" clId="{002822DB-EE53-4F2A-8F03-1C9D4C4542CA}" dt="2025-07-18T17:44:23.410" v="596" actId="1582"/>
+          <ac:cxnSpMkLst>
+            <pc:docMk/>
+            <pc:sldMk cId="975446107" sldId="466"/>
+            <ac:cxnSpMk id="4" creationId="{D4D97E3C-8D7F-755B-E041-AF4D2A522FB4}"/>
           </ac:cxnSpMkLst>
         </pc:cxnChg>
       </pc:sldChg>
@@ -335,14 +338,6 @@
           <pc:docMk/>
           <pc:sldMk cId="3310950541" sldId="468"/>
         </pc:sldMkLst>
-        <pc:picChg chg="del mod">
-          <ac:chgData name="Lines, Todd" userId="afaf7c3a-e8aa-4568-882a-02ad8f9e19b0" providerId="ADAL" clId="{002822DB-EE53-4F2A-8F03-1C9D4C4542CA}" dt="2025-07-08T19:19:35.696" v="588" actId="21"/>
-          <ac:picMkLst>
-            <pc:docMk/>
-            <pc:sldMk cId="3310950541" sldId="468"/>
-            <ac:picMk id="3" creationId="{05CD7CC5-BC8C-FD4A-DE26-6B2703E279D7}"/>
-          </ac:picMkLst>
-        </pc:picChg>
         <pc:picChg chg="add mod">
           <ac:chgData name="Lines, Todd" userId="afaf7c3a-e8aa-4568-882a-02ad8f9e19b0" providerId="ADAL" clId="{002822DB-EE53-4F2A-8F03-1C9D4C4542CA}" dt="2025-07-08T19:19:20.174" v="585" actId="1076"/>
           <ac:picMkLst>
@@ -361,33 +356,129 @@
         </pc:cxnChg>
       </pc:sldChg>
       <pc:sldChg chg="addSp delSp modSp new mod">
-        <pc:chgData name="Lines, Todd" userId="afaf7c3a-e8aa-4568-882a-02ad8f9e19b0" providerId="ADAL" clId="{002822DB-EE53-4F2A-8F03-1C9D4C4542CA}" dt="2025-07-08T19:21:03.987" v="593" actId="21"/>
+        <pc:chgData name="Lines, Todd" userId="afaf7c3a-e8aa-4568-882a-02ad8f9e19b0" providerId="ADAL" clId="{002822DB-EE53-4F2A-8F03-1C9D4C4542CA}" dt="2025-07-18T17:50:38.547" v="636" actId="21"/>
         <pc:sldMkLst>
           <pc:docMk/>
           <pc:sldMk cId="3744036023" sldId="469"/>
         </pc:sldMkLst>
-        <pc:picChg chg="del mod">
-          <ac:chgData name="Lines, Todd" userId="afaf7c3a-e8aa-4568-882a-02ad8f9e19b0" providerId="ADAL" clId="{002822DB-EE53-4F2A-8F03-1C9D4C4542CA}" dt="2025-07-08T19:21:03.987" v="593" actId="21"/>
-          <ac:picMkLst>
-            <pc:docMk/>
-            <pc:sldMk cId="3744036023" sldId="469"/>
-            <ac:picMk id="3" creationId="{FD57C153-AF8E-E43A-A0CB-64ECD2BE0F03}"/>
-          </ac:picMkLst>
-        </pc:picChg>
-        <pc:picChg chg="add mod">
-          <ac:chgData name="Lines, Todd" userId="afaf7c3a-e8aa-4568-882a-02ad8f9e19b0" providerId="ADAL" clId="{002822DB-EE53-4F2A-8F03-1C9D4C4542CA}" dt="2025-07-03T22:37:10.740" v="55" actId="14100"/>
+        <pc:picChg chg="add del mod">
+          <ac:chgData name="Lines, Todd" userId="afaf7c3a-e8aa-4568-882a-02ad8f9e19b0" providerId="ADAL" clId="{002822DB-EE53-4F2A-8F03-1C9D4C4542CA}" dt="2025-07-18T17:49:58.698" v="628" actId="478"/>
           <ac:picMkLst>
             <pc:docMk/>
             <pc:sldMk cId="3744036023" sldId="469"/>
             <ac:picMk id="5" creationId="{E8B8C2B6-2DC3-3AF5-4331-B1B2288CFE46}"/>
           </ac:picMkLst>
         </pc:picChg>
-        <pc:cxnChg chg="add mod">
-          <ac:chgData name="Lines, Todd" userId="afaf7c3a-e8aa-4568-882a-02ad8f9e19b0" providerId="ADAL" clId="{002822DB-EE53-4F2A-8F03-1C9D4C4542CA}" dt="2025-07-08T19:20:50.949" v="591" actId="1035"/>
+        <pc:picChg chg="del mod">
+          <ac:chgData name="Lines, Todd" userId="afaf7c3a-e8aa-4568-882a-02ad8f9e19b0" providerId="ADAL" clId="{002822DB-EE53-4F2A-8F03-1C9D4C4542CA}" dt="2025-07-18T17:48:05.763" v="611" actId="21"/>
+          <ac:picMkLst>
+            <pc:docMk/>
+            <pc:sldMk cId="3744036023" sldId="469"/>
+            <ac:picMk id="8" creationId="{73F4AFD3-BF4C-7479-8F72-7DECCD07E1A2}"/>
+          </ac:picMkLst>
+        </pc:picChg>
+        <pc:picChg chg="add del mod">
+          <ac:chgData name="Lines, Todd" userId="afaf7c3a-e8aa-4568-882a-02ad8f9e19b0" providerId="ADAL" clId="{002822DB-EE53-4F2A-8F03-1C9D4C4542CA}" dt="2025-07-18T17:49:24.184" v="622" actId="478"/>
+          <ac:picMkLst>
+            <pc:docMk/>
+            <pc:sldMk cId="3744036023" sldId="469"/>
+            <ac:picMk id="10" creationId="{DE93C005-7A88-8067-562F-8EC4C9DCB96F}"/>
+          </ac:picMkLst>
+        </pc:picChg>
+        <pc:picChg chg="add mod">
+          <ac:chgData name="Lines, Todd" userId="afaf7c3a-e8aa-4568-882a-02ad8f9e19b0" providerId="ADAL" clId="{002822DB-EE53-4F2A-8F03-1C9D4C4542CA}" dt="2025-07-18T17:49:29.618" v="623"/>
+          <ac:picMkLst>
+            <pc:docMk/>
+            <pc:sldMk cId="3744036023" sldId="469"/>
+            <ac:picMk id="14" creationId="{8E9D90FE-9859-9131-6FEF-9302CAFC1003}"/>
+          </ac:picMkLst>
+        </pc:picChg>
+        <pc:picChg chg="del mod">
+          <ac:chgData name="Lines, Todd" userId="afaf7c3a-e8aa-4568-882a-02ad8f9e19b0" providerId="ADAL" clId="{002822DB-EE53-4F2A-8F03-1C9D4C4542CA}" dt="2025-07-18T17:49:48.970" v="626" actId="478"/>
+          <ac:picMkLst>
+            <pc:docMk/>
+            <pc:sldMk cId="3744036023" sldId="469"/>
+            <ac:picMk id="18" creationId="{9302FB6F-5AB7-2EA5-0F30-7DE535A569F0}"/>
+          </ac:picMkLst>
+        </pc:picChg>
+        <pc:picChg chg="del mod">
+          <ac:chgData name="Lines, Todd" userId="afaf7c3a-e8aa-4568-882a-02ad8f9e19b0" providerId="ADAL" clId="{002822DB-EE53-4F2A-8F03-1C9D4C4542CA}" dt="2025-07-18T17:50:38.547" v="636" actId="21"/>
+          <ac:picMkLst>
+            <pc:docMk/>
+            <pc:sldMk cId="3744036023" sldId="469"/>
+            <ac:picMk id="19" creationId="{FA5AEBA2-5702-B30C-513A-2CE84FE664C6}"/>
+          </ac:picMkLst>
+        </pc:picChg>
+        <pc:cxnChg chg="add del mod ord">
+          <ac:chgData name="Lines, Todd" userId="afaf7c3a-e8aa-4568-882a-02ad8f9e19b0" providerId="ADAL" clId="{002822DB-EE53-4F2A-8F03-1C9D4C4542CA}" dt="2025-07-18T17:50:05.801" v="629" actId="478"/>
           <ac:cxnSpMkLst>
             <pc:docMk/>
             <pc:sldMk cId="3744036023" sldId="469"/>
             <ac:cxnSpMk id="2" creationId="{2B34615C-03A8-8887-A787-5DFCE08ABDB9}"/>
+          </ac:cxnSpMkLst>
+        </pc:cxnChg>
+        <pc:cxnChg chg="add mod">
+          <ac:chgData name="Lines, Todd" userId="afaf7c3a-e8aa-4568-882a-02ad8f9e19b0" providerId="ADAL" clId="{002822DB-EE53-4F2A-8F03-1C9D4C4542CA}" dt="2025-07-18T17:47:53.609" v="609" actId="1036"/>
+          <ac:cxnSpMkLst>
+            <pc:docMk/>
+            <pc:sldMk cId="3744036023" sldId="469"/>
+            <ac:cxnSpMk id="4" creationId="{ACFF82DA-979A-3AFB-D691-10055ACDC352}"/>
+          </ac:cxnSpMkLst>
+        </pc:cxnChg>
+        <pc:cxnChg chg="add mod">
+          <ac:chgData name="Lines, Todd" userId="afaf7c3a-e8aa-4568-882a-02ad8f9e19b0" providerId="ADAL" clId="{002822DB-EE53-4F2A-8F03-1C9D4C4542CA}" dt="2025-07-18T17:48:58.895" v="618" actId="1582"/>
+          <ac:cxnSpMkLst>
+            <pc:docMk/>
+            <pc:sldMk cId="3744036023" sldId="469"/>
+            <ac:cxnSpMk id="7" creationId="{6FBF6BC9-6961-A8F3-984A-481B042B1B81}"/>
+          </ac:cxnSpMkLst>
+        </pc:cxnChg>
+        <pc:cxnChg chg="add del mod">
+          <ac:chgData name="Lines, Todd" userId="afaf7c3a-e8aa-4568-882a-02ad8f9e19b0" providerId="ADAL" clId="{002822DB-EE53-4F2A-8F03-1C9D4C4542CA}" dt="2025-07-18T17:49:24.184" v="622" actId="478"/>
+          <ac:cxnSpMkLst>
+            <pc:docMk/>
+            <pc:sldMk cId="3744036023" sldId="469"/>
+            <ac:cxnSpMk id="11" creationId="{E88E7EB0-37A8-DD84-29E2-8D97C52D519E}"/>
+          </ac:cxnSpMkLst>
+        </pc:cxnChg>
+        <pc:cxnChg chg="add del mod">
+          <ac:chgData name="Lines, Todd" userId="afaf7c3a-e8aa-4568-882a-02ad8f9e19b0" providerId="ADAL" clId="{002822DB-EE53-4F2A-8F03-1C9D4C4542CA}" dt="2025-07-18T17:49:24.184" v="622" actId="478"/>
+          <ac:cxnSpMkLst>
+            <pc:docMk/>
+            <pc:sldMk cId="3744036023" sldId="469"/>
+            <ac:cxnSpMk id="12" creationId="{83BD2C6C-B085-903F-6CFF-3FCB9ED83600}"/>
+          </ac:cxnSpMkLst>
+        </pc:cxnChg>
+        <pc:cxnChg chg="add del mod">
+          <ac:chgData name="Lines, Todd" userId="afaf7c3a-e8aa-4568-882a-02ad8f9e19b0" providerId="ADAL" clId="{002822DB-EE53-4F2A-8F03-1C9D4C4542CA}" dt="2025-07-18T17:49:24.184" v="622" actId="478"/>
+          <ac:cxnSpMkLst>
+            <pc:docMk/>
+            <pc:sldMk cId="3744036023" sldId="469"/>
+            <ac:cxnSpMk id="13" creationId="{78EA0778-61EE-D51F-3AAD-68A7AAB86584}"/>
+          </ac:cxnSpMkLst>
+        </pc:cxnChg>
+        <pc:cxnChg chg="add mod">
+          <ac:chgData name="Lines, Todd" userId="afaf7c3a-e8aa-4568-882a-02ad8f9e19b0" providerId="ADAL" clId="{002822DB-EE53-4F2A-8F03-1C9D4C4542CA}" dt="2025-07-18T17:49:29.618" v="623"/>
+          <ac:cxnSpMkLst>
+            <pc:docMk/>
+            <pc:sldMk cId="3744036023" sldId="469"/>
+            <ac:cxnSpMk id="15" creationId="{7CC3A4AD-E3C7-1F8F-8E47-BEF3A11FA1EB}"/>
+          </ac:cxnSpMkLst>
+        </pc:cxnChg>
+        <pc:cxnChg chg="add mod">
+          <ac:chgData name="Lines, Todd" userId="afaf7c3a-e8aa-4568-882a-02ad8f9e19b0" providerId="ADAL" clId="{002822DB-EE53-4F2A-8F03-1C9D4C4542CA}" dt="2025-07-18T17:49:29.618" v="623"/>
+          <ac:cxnSpMkLst>
+            <pc:docMk/>
+            <pc:sldMk cId="3744036023" sldId="469"/>
+            <ac:cxnSpMk id="16" creationId="{9CB70B8F-6FCD-7EBD-F47D-134E1E54C66E}"/>
+          </ac:cxnSpMkLst>
+        </pc:cxnChg>
+        <pc:cxnChg chg="add mod">
+          <ac:chgData name="Lines, Todd" userId="afaf7c3a-e8aa-4568-882a-02ad8f9e19b0" providerId="ADAL" clId="{002822DB-EE53-4F2A-8F03-1C9D4C4542CA}" dt="2025-07-18T17:50:23.922" v="633" actId="692"/>
+          <ac:cxnSpMkLst>
+            <pc:docMk/>
+            <pc:sldMk cId="3744036023" sldId="469"/>
+            <ac:cxnSpMk id="17" creationId="{51F59622-C043-2EC3-B061-4FFA439E6FEB}"/>
           </ac:cxnSpMkLst>
         </pc:cxnChg>
       </pc:sldChg>
@@ -488,14 +579,6 @@
             <ac:picMk id="4" creationId="{6CCE7247-AF99-178F-8AA3-BACE43C1D3FE}"/>
           </ac:picMkLst>
         </pc:picChg>
-        <pc:picChg chg="del">
-          <ac:chgData name="Lines, Todd" userId="afaf7c3a-e8aa-4568-882a-02ad8f9e19b0" providerId="ADAL" clId="{002822DB-EE53-4F2A-8F03-1C9D4C4542CA}" dt="2025-07-08T16:00:42.342" v="234" actId="478"/>
-          <ac:picMkLst>
-            <pc:docMk/>
-            <pc:sldMk cId="1455729989" sldId="475"/>
-            <ac:picMk id="5" creationId="{304CB9DA-F391-D172-BD0C-D63664D918C3}"/>
-          </ac:picMkLst>
-        </pc:picChg>
         <pc:cxnChg chg="mod">
           <ac:chgData name="Lines, Todd" userId="afaf7c3a-e8aa-4568-882a-02ad8f9e19b0" providerId="ADAL" clId="{002822DB-EE53-4F2A-8F03-1C9D4C4542CA}" dt="2025-07-08T19:18:35.621" v="576" actId="1035"/>
           <ac:cxnSpMkLst>
@@ -534,22 +617,6 @@
             <ac:picMk id="4" creationId="{44953FE4-1737-7FA7-D99D-6BC35F8D05F6}"/>
           </ac:picMkLst>
         </pc:picChg>
-        <pc:picChg chg="del">
-          <ac:chgData name="Lines, Todd" userId="afaf7c3a-e8aa-4568-882a-02ad8f9e19b0" providerId="ADAL" clId="{002822DB-EE53-4F2A-8F03-1C9D4C4542CA}" dt="2025-07-08T16:02:29.477" v="383" actId="478"/>
-          <ac:picMkLst>
-            <pc:docMk/>
-            <pc:sldMk cId="148843540" sldId="477"/>
-            <ac:picMk id="5" creationId="{0100523C-7374-467A-E24C-168B13AE907D}"/>
-          </ac:picMkLst>
-        </pc:picChg>
-        <pc:cxnChg chg="del">
-          <ac:chgData name="Lines, Todd" userId="afaf7c3a-e8aa-4568-882a-02ad8f9e19b0" providerId="ADAL" clId="{002822DB-EE53-4F2A-8F03-1C9D4C4542CA}" dt="2025-07-08T16:02:29.477" v="383" actId="478"/>
-          <ac:cxnSpMkLst>
-            <pc:docMk/>
-            <pc:sldMk cId="148843540" sldId="477"/>
-            <ac:cxnSpMk id="6" creationId="{4ABCDCF7-870F-DB22-F53A-398D8725B3D7}"/>
-          </ac:cxnSpMkLst>
-        </pc:cxnChg>
         <pc:cxnChg chg="add mod">
           <ac:chgData name="Lines, Todd" userId="afaf7c3a-e8aa-4568-882a-02ad8f9e19b0" providerId="ADAL" clId="{002822DB-EE53-4F2A-8F03-1C9D4C4542CA}" dt="2025-07-08T19:35:40.494" v="594" actId="1035"/>
           <ac:cxnSpMkLst>
@@ -560,7 +627,7 @@
         </pc:cxnChg>
       </pc:sldChg>
       <pc:sldChg chg="addSp delSp modSp add mod">
-        <pc:chgData name="Lines, Todd" userId="afaf7c3a-e8aa-4568-882a-02ad8f9e19b0" providerId="ADAL" clId="{002822DB-EE53-4F2A-8F03-1C9D4C4542CA}" dt="2025-07-08T18:43:06.493" v="455" actId="313"/>
+        <pc:chgData name="Lines, Todd" userId="afaf7c3a-e8aa-4568-882a-02ad8f9e19b0" providerId="ADAL" clId="{002822DB-EE53-4F2A-8F03-1C9D4C4542CA}" dt="2025-07-18T17:51:46.494" v="641" actId="21"/>
         <pc:sldMkLst>
           <pc:docMk/>
           <pc:sldMk cId="6673116" sldId="478"/>
@@ -582,15 +649,23 @@
           </ac:picMkLst>
         </pc:picChg>
         <pc:picChg chg="del">
-          <ac:chgData name="Lines, Todd" userId="afaf7c3a-e8aa-4568-882a-02ad8f9e19b0" providerId="ADAL" clId="{002822DB-EE53-4F2A-8F03-1C9D4C4542CA}" dt="2025-07-08T16:03:08.950" v="386" actId="478"/>
+          <ac:chgData name="Lines, Todd" userId="afaf7c3a-e8aa-4568-882a-02ad8f9e19b0" providerId="ADAL" clId="{002822DB-EE53-4F2A-8F03-1C9D4C4542CA}" dt="2025-07-18T17:51:24.042" v="637" actId="478"/>
           <ac:picMkLst>
             <pc:docMk/>
             <pc:sldMk cId="6673116" sldId="478"/>
-            <ac:picMk id="5" creationId="{DB624585-6601-D697-745A-F9CA914D07E9}"/>
+            <ac:picMk id="5" creationId="{170865E7-A6BD-1A32-5507-3A243EA9EF79}"/>
+          </ac:picMkLst>
+        </pc:picChg>
+        <pc:picChg chg="del mod">
+          <ac:chgData name="Lines, Todd" userId="afaf7c3a-e8aa-4568-882a-02ad8f9e19b0" providerId="ADAL" clId="{002822DB-EE53-4F2A-8F03-1C9D4C4542CA}" dt="2025-07-18T17:51:46.494" v="641" actId="21"/>
+          <ac:picMkLst>
+            <pc:docMk/>
+            <pc:sldMk cId="6673116" sldId="478"/>
+            <ac:picMk id="7" creationId="{CF33ACDC-A152-AF34-E86F-0F0BF18DF036}"/>
           </ac:picMkLst>
         </pc:picChg>
         <pc:cxnChg chg="mod ord">
-          <ac:chgData name="Lines, Todd" userId="afaf7c3a-e8aa-4568-882a-02ad8f9e19b0" providerId="ADAL" clId="{002822DB-EE53-4F2A-8F03-1C9D4C4542CA}" dt="2025-07-08T18:41:00.239" v="449" actId="1035"/>
+          <ac:chgData name="Lines, Todd" userId="afaf7c3a-e8aa-4568-882a-02ad8f9e19b0" providerId="ADAL" clId="{002822DB-EE53-4F2A-8F03-1C9D4C4542CA}" dt="2025-07-18T17:51:35.140" v="639" actId="692"/>
           <ac:cxnSpMkLst>
             <pc:docMk/>
             <pc:sldMk cId="6673116" sldId="478"/>
@@ -612,22 +687,6 @@
             <ac:picMk id="4" creationId="{9962E8B0-9050-503B-9091-1EDA47E2D28F}"/>
           </ac:picMkLst>
         </pc:picChg>
-        <pc:picChg chg="del">
-          <ac:chgData name="Lines, Todd" userId="afaf7c3a-e8aa-4568-882a-02ad8f9e19b0" providerId="ADAL" clId="{002822DB-EE53-4F2A-8F03-1C9D4C4542CA}" dt="2025-07-08T18:42:03.360" v="452" actId="478"/>
-          <ac:picMkLst>
-            <pc:docMk/>
-            <pc:sldMk cId="1395796797" sldId="479"/>
-            <ac:picMk id="5" creationId="{9C4172B2-C540-B805-DE82-2319F4225DFB}"/>
-          </ac:picMkLst>
-        </pc:picChg>
-        <pc:cxnChg chg="del">
-          <ac:chgData name="Lines, Todd" userId="afaf7c3a-e8aa-4568-882a-02ad8f9e19b0" providerId="ADAL" clId="{002822DB-EE53-4F2A-8F03-1C9D4C4542CA}" dt="2025-07-08T18:42:03.360" v="452" actId="478"/>
-          <ac:cxnSpMkLst>
-            <pc:docMk/>
-            <pc:sldMk cId="1395796797" sldId="479"/>
-            <ac:cxnSpMk id="6" creationId="{68E3D5C1-BEAF-C61A-766D-38696C34D103}"/>
-          </ac:cxnSpMkLst>
-        </pc:cxnChg>
         <pc:cxnChg chg="add mod">
           <ac:chgData name="Lines, Todd" userId="afaf7c3a-e8aa-4568-882a-02ad8f9e19b0" providerId="ADAL" clId="{002822DB-EE53-4F2A-8F03-1C9D4C4542CA}" dt="2025-07-08T18:42:13.563" v="454" actId="1076"/>
           <ac:cxnSpMkLst>
@@ -643,14 +702,6 @@
           <pc:docMk/>
           <pc:sldMk cId="1397824895" sldId="480"/>
         </pc:sldMkLst>
-        <pc:picChg chg="add del mod">
-          <ac:chgData name="Lines, Todd" userId="afaf7c3a-e8aa-4568-882a-02ad8f9e19b0" providerId="ADAL" clId="{002822DB-EE53-4F2A-8F03-1C9D4C4542CA}" dt="2025-07-08T18:49:44.201" v="459" actId="478"/>
-          <ac:picMkLst>
-            <pc:docMk/>
-            <pc:sldMk cId="1397824895" sldId="480"/>
-            <ac:picMk id="5" creationId="{F2E42F06-EEEB-8549-5BBE-F5813A72E876}"/>
-          </ac:picMkLst>
-        </pc:picChg>
         <pc:picChg chg="add">
           <ac:chgData name="Lines, Todd" userId="afaf7c3a-e8aa-4568-882a-02ad8f9e19b0" providerId="ADAL" clId="{002822DB-EE53-4F2A-8F03-1C9D4C4542CA}" dt="2025-07-08T18:50:05.430" v="460" actId="22"/>
           <ac:picMkLst>
@@ -722,6 +773,439 @@
     </pc:docChg>
   </pc:docChgLst>
 </pc:chgInfo>
+</file>
+
+<file path=ppt/notesMasters/notesMaster1.xml><?xml version="1.0" encoding="utf-8"?>
+<p:notesMaster xmlns:a="http://schemas.openxmlformats.org/drawingml/2006/main" xmlns:r="http://schemas.openxmlformats.org/officeDocument/2006/relationships" xmlns:p="http://schemas.openxmlformats.org/presentationml/2006/main">
+  <p:cSld>
+    <p:bg>
+      <p:bgRef idx="1001">
+        <a:schemeClr val="bg1"/>
+      </p:bgRef>
+    </p:bg>
+    <p:spTree>
+      <p:nvGrpSpPr>
+        <p:cNvPr id="1" name=""/>
+        <p:cNvGrpSpPr/>
+        <p:nvPr/>
+      </p:nvGrpSpPr>
+      <p:grpSpPr>
+        <a:xfrm>
+          <a:off x="0" y="0"/>
+          <a:ext cx="0" cy="0"/>
+          <a:chOff x="0" y="0"/>
+          <a:chExt cx="0" cy="0"/>
+        </a:xfrm>
+      </p:grpSpPr>
+      <p:sp>
+        <p:nvSpPr>
+          <p:cNvPr id="2" name="Header Placeholder 1"/>
+          <p:cNvSpPr>
+            <a:spLocks noGrp="1"/>
+          </p:cNvSpPr>
+          <p:nvPr>
+            <p:ph type="hdr" sz="quarter"/>
+          </p:nvPr>
+        </p:nvSpPr>
+        <p:spPr>
+          <a:xfrm>
+            <a:off x="0" y="0"/>
+            <a:ext cx="2971800" cy="458788"/>
+          </a:xfrm>
+          <a:prstGeom prst="rect">
+            <a:avLst/>
+          </a:prstGeom>
+        </p:spPr>
+        <p:txBody>
+          <a:bodyPr vert="horz" lIns="91440" tIns="45720" rIns="91440" bIns="45720" rtlCol="0"/>
+          <a:lstStyle>
+            <a:lvl1pPr algn="l">
+              <a:defRPr sz="1200"/>
+            </a:lvl1pPr>
+          </a:lstStyle>
+          <a:p>
+            <a:endParaRPr lang="en-US"/>
+          </a:p>
+        </p:txBody>
+      </p:sp>
+      <p:sp>
+        <p:nvSpPr>
+          <p:cNvPr id="3" name="Date Placeholder 2"/>
+          <p:cNvSpPr>
+            <a:spLocks noGrp="1"/>
+          </p:cNvSpPr>
+          <p:nvPr>
+            <p:ph type="dt" idx="1"/>
+          </p:nvPr>
+        </p:nvSpPr>
+        <p:spPr>
+          <a:xfrm>
+            <a:off x="3884613" y="0"/>
+            <a:ext cx="2971800" cy="458788"/>
+          </a:xfrm>
+          <a:prstGeom prst="rect">
+            <a:avLst/>
+          </a:prstGeom>
+        </p:spPr>
+        <p:txBody>
+          <a:bodyPr vert="horz" lIns="91440" tIns="45720" rIns="91440" bIns="45720" rtlCol="0"/>
+          <a:lstStyle>
+            <a:lvl1pPr algn="r">
+              <a:defRPr sz="1200"/>
+            </a:lvl1pPr>
+          </a:lstStyle>
+          <a:p>
+            <a:fld id="{87F53586-FF55-42A0-B419-AF2ACE7CF085}" type="datetimeFigureOut">
+              <a:rPr lang="en-US" smtClean="0"/>
+              <a:t>7/18/2025</a:t>
+            </a:fld>
+            <a:endParaRPr lang="en-US"/>
+          </a:p>
+        </p:txBody>
+      </p:sp>
+      <p:sp>
+        <p:nvSpPr>
+          <p:cNvPr id="4" name="Slide Image Placeholder 3"/>
+          <p:cNvSpPr>
+            <a:spLocks noGrp="1" noRot="1" noChangeAspect="1"/>
+          </p:cNvSpPr>
+          <p:nvPr>
+            <p:ph type="sldImg" idx="2"/>
+          </p:nvPr>
+        </p:nvSpPr>
+        <p:spPr>
+          <a:xfrm>
+            <a:off x="1371600" y="1143000"/>
+            <a:ext cx="4114800" cy="3086100"/>
+          </a:xfrm>
+          <a:prstGeom prst="rect">
+            <a:avLst/>
+          </a:prstGeom>
+          <a:noFill/>
+          <a:ln w="12700">
+            <a:solidFill>
+              <a:prstClr val="black"/>
+            </a:solidFill>
+          </a:ln>
+        </p:spPr>
+        <p:txBody>
+          <a:bodyPr vert="horz" lIns="91440" tIns="45720" rIns="91440" bIns="45720" rtlCol="0" anchor="ctr"/>
+          <a:lstStyle/>
+          <a:p>
+            <a:endParaRPr lang="en-US"/>
+          </a:p>
+        </p:txBody>
+      </p:sp>
+      <p:sp>
+        <p:nvSpPr>
+          <p:cNvPr id="5" name="Notes Placeholder 4"/>
+          <p:cNvSpPr>
+            <a:spLocks noGrp="1"/>
+          </p:cNvSpPr>
+          <p:nvPr>
+            <p:ph type="body" sz="quarter" idx="3"/>
+          </p:nvPr>
+        </p:nvSpPr>
+        <p:spPr>
+          <a:xfrm>
+            <a:off x="685800" y="4400550"/>
+            <a:ext cx="5486400" cy="3600450"/>
+          </a:xfrm>
+          <a:prstGeom prst="rect">
+            <a:avLst/>
+          </a:prstGeom>
+        </p:spPr>
+        <p:txBody>
+          <a:bodyPr vert="horz" lIns="91440" tIns="45720" rIns="91440" bIns="45720" rtlCol="0"/>
+          <a:lstStyle/>
+          <a:p>
+            <a:pPr lvl="0"/>
+            <a:r>
+              <a:rPr lang="en-US"/>
+              <a:t>Click to edit Master text styles</a:t>
+            </a:r>
+          </a:p>
+          <a:p>
+            <a:pPr lvl="1"/>
+            <a:r>
+              <a:rPr lang="en-US"/>
+              <a:t>Second level</a:t>
+            </a:r>
+          </a:p>
+          <a:p>
+            <a:pPr lvl="2"/>
+            <a:r>
+              <a:rPr lang="en-US"/>
+              <a:t>Third level</a:t>
+            </a:r>
+          </a:p>
+          <a:p>
+            <a:pPr lvl="3"/>
+            <a:r>
+              <a:rPr lang="en-US"/>
+              <a:t>Fourth level</a:t>
+            </a:r>
+          </a:p>
+          <a:p>
+            <a:pPr lvl="4"/>
+            <a:r>
+              <a:rPr lang="en-US"/>
+              <a:t>Fifth level</a:t>
+            </a:r>
+          </a:p>
+        </p:txBody>
+      </p:sp>
+      <p:sp>
+        <p:nvSpPr>
+          <p:cNvPr id="6" name="Footer Placeholder 5"/>
+          <p:cNvSpPr>
+            <a:spLocks noGrp="1"/>
+          </p:cNvSpPr>
+          <p:nvPr>
+            <p:ph type="ftr" sz="quarter" idx="4"/>
+          </p:nvPr>
+        </p:nvSpPr>
+        <p:spPr>
+          <a:xfrm>
+            <a:off x="0" y="8685213"/>
+            <a:ext cx="2971800" cy="458787"/>
+          </a:xfrm>
+          <a:prstGeom prst="rect">
+            <a:avLst/>
+          </a:prstGeom>
+        </p:spPr>
+        <p:txBody>
+          <a:bodyPr vert="horz" lIns="91440" tIns="45720" rIns="91440" bIns="45720" rtlCol="0" anchor="b"/>
+          <a:lstStyle>
+            <a:lvl1pPr algn="l">
+              <a:defRPr sz="1200"/>
+            </a:lvl1pPr>
+          </a:lstStyle>
+          <a:p>
+            <a:endParaRPr lang="en-US"/>
+          </a:p>
+        </p:txBody>
+      </p:sp>
+      <p:sp>
+        <p:nvSpPr>
+          <p:cNvPr id="7" name="Slide Number Placeholder 6"/>
+          <p:cNvSpPr>
+            <a:spLocks noGrp="1"/>
+          </p:cNvSpPr>
+          <p:nvPr>
+            <p:ph type="sldNum" sz="quarter" idx="5"/>
+          </p:nvPr>
+        </p:nvSpPr>
+        <p:spPr>
+          <a:xfrm>
+            <a:off x="3884613" y="8685213"/>
+            <a:ext cx="2971800" cy="458787"/>
+          </a:xfrm>
+          <a:prstGeom prst="rect">
+            <a:avLst/>
+          </a:prstGeom>
+        </p:spPr>
+        <p:txBody>
+          <a:bodyPr vert="horz" lIns="91440" tIns="45720" rIns="91440" bIns="45720" rtlCol="0" anchor="b"/>
+          <a:lstStyle>
+            <a:lvl1pPr algn="r">
+              <a:defRPr sz="1200"/>
+            </a:lvl1pPr>
+          </a:lstStyle>
+          <a:p>
+            <a:fld id="{9765AF27-32A6-4D2B-8C54-2780EFC37AB4}" type="slidenum">
+              <a:rPr lang="en-US" smtClean="0"/>
+              <a:t>‹#›</a:t>
+            </a:fld>
+            <a:endParaRPr lang="en-US"/>
+          </a:p>
+        </p:txBody>
+      </p:sp>
+    </p:spTree>
+    <p:extLst>
+      <p:ext uri="{BB962C8B-B14F-4D97-AF65-F5344CB8AC3E}">
+        <p14:creationId xmlns:p14="http://schemas.microsoft.com/office/powerpoint/2010/main" val="3057104934"/>
+      </p:ext>
+    </p:extLst>
+  </p:cSld>
+  <p:clrMap bg1="lt1" tx1="dk1" bg2="lt2" tx2="dk2" accent1="accent1" accent2="accent2" accent3="accent3" accent4="accent4" accent5="accent5" accent6="accent6" hlink="hlink" folHlink="folHlink"/>
+  <p:notesStyle>
+    <a:lvl1pPr marL="0" algn="l" defTabSz="914400" rtl="0" eaLnBrk="1" latinLnBrk="0" hangingPunct="1">
+      <a:defRPr sz="1200" kern="1200">
+        <a:solidFill>
+          <a:schemeClr val="tx1"/>
+        </a:solidFill>
+        <a:latin typeface="+mn-lt"/>
+        <a:ea typeface="+mn-ea"/>
+        <a:cs typeface="+mn-cs"/>
+      </a:defRPr>
+    </a:lvl1pPr>
+    <a:lvl2pPr marL="457200" algn="l" defTabSz="914400" rtl="0" eaLnBrk="1" latinLnBrk="0" hangingPunct="1">
+      <a:defRPr sz="1200" kern="1200">
+        <a:solidFill>
+          <a:schemeClr val="tx1"/>
+        </a:solidFill>
+        <a:latin typeface="+mn-lt"/>
+        <a:ea typeface="+mn-ea"/>
+        <a:cs typeface="+mn-cs"/>
+      </a:defRPr>
+    </a:lvl2pPr>
+    <a:lvl3pPr marL="914400" algn="l" defTabSz="914400" rtl="0" eaLnBrk="1" latinLnBrk="0" hangingPunct="1">
+      <a:defRPr sz="1200" kern="1200">
+        <a:solidFill>
+          <a:schemeClr val="tx1"/>
+        </a:solidFill>
+        <a:latin typeface="+mn-lt"/>
+        <a:ea typeface="+mn-ea"/>
+        <a:cs typeface="+mn-cs"/>
+      </a:defRPr>
+    </a:lvl3pPr>
+    <a:lvl4pPr marL="1371600" algn="l" defTabSz="914400" rtl="0" eaLnBrk="1" latinLnBrk="0" hangingPunct="1">
+      <a:defRPr sz="1200" kern="1200">
+        <a:solidFill>
+          <a:schemeClr val="tx1"/>
+        </a:solidFill>
+        <a:latin typeface="+mn-lt"/>
+        <a:ea typeface="+mn-ea"/>
+        <a:cs typeface="+mn-cs"/>
+      </a:defRPr>
+    </a:lvl4pPr>
+    <a:lvl5pPr marL="1828800" algn="l" defTabSz="914400" rtl="0" eaLnBrk="1" latinLnBrk="0" hangingPunct="1">
+      <a:defRPr sz="1200" kern="1200">
+        <a:solidFill>
+          <a:schemeClr val="tx1"/>
+        </a:solidFill>
+        <a:latin typeface="+mn-lt"/>
+        <a:ea typeface="+mn-ea"/>
+        <a:cs typeface="+mn-cs"/>
+      </a:defRPr>
+    </a:lvl5pPr>
+    <a:lvl6pPr marL="2286000" algn="l" defTabSz="914400" rtl="0" eaLnBrk="1" latinLnBrk="0" hangingPunct="1">
+      <a:defRPr sz="1200" kern="1200">
+        <a:solidFill>
+          <a:schemeClr val="tx1"/>
+        </a:solidFill>
+        <a:latin typeface="+mn-lt"/>
+        <a:ea typeface="+mn-ea"/>
+        <a:cs typeface="+mn-cs"/>
+      </a:defRPr>
+    </a:lvl6pPr>
+    <a:lvl7pPr marL="2743200" algn="l" defTabSz="914400" rtl="0" eaLnBrk="1" latinLnBrk="0" hangingPunct="1">
+      <a:defRPr sz="1200" kern="1200">
+        <a:solidFill>
+          <a:schemeClr val="tx1"/>
+        </a:solidFill>
+        <a:latin typeface="+mn-lt"/>
+        <a:ea typeface="+mn-ea"/>
+        <a:cs typeface="+mn-cs"/>
+      </a:defRPr>
+    </a:lvl7pPr>
+    <a:lvl8pPr marL="3200400" algn="l" defTabSz="914400" rtl="0" eaLnBrk="1" latinLnBrk="0" hangingPunct="1">
+      <a:defRPr sz="1200" kern="1200">
+        <a:solidFill>
+          <a:schemeClr val="tx1"/>
+        </a:solidFill>
+        <a:latin typeface="+mn-lt"/>
+        <a:ea typeface="+mn-ea"/>
+        <a:cs typeface="+mn-cs"/>
+      </a:defRPr>
+    </a:lvl8pPr>
+    <a:lvl9pPr marL="3657600" algn="l" defTabSz="914400" rtl="0" eaLnBrk="1" latinLnBrk="0" hangingPunct="1">
+      <a:defRPr sz="1200" kern="1200">
+        <a:solidFill>
+          <a:schemeClr val="tx1"/>
+        </a:solidFill>
+        <a:latin typeface="+mn-lt"/>
+        <a:ea typeface="+mn-ea"/>
+        <a:cs typeface="+mn-cs"/>
+      </a:defRPr>
+    </a:lvl9pPr>
+  </p:notesStyle>
+</p:notesMaster>
+</file>
+
+<file path=ppt/notesSlides/notesSlide1.xml><?xml version="1.0" encoding="utf-8"?>
+<p:notes xmlns:a="http://schemas.openxmlformats.org/drawingml/2006/main" xmlns:r="http://schemas.openxmlformats.org/officeDocument/2006/relationships" xmlns:p="http://schemas.openxmlformats.org/presentationml/2006/main">
+  <p:cSld>
+    <p:spTree>
+      <p:nvGrpSpPr>
+        <p:cNvPr id="1" name=""/>
+        <p:cNvGrpSpPr/>
+        <p:nvPr/>
+      </p:nvGrpSpPr>
+      <p:grpSpPr>
+        <a:xfrm>
+          <a:off x="0" y="0"/>
+          <a:ext cx="0" cy="0"/>
+          <a:chOff x="0" y="0"/>
+          <a:chExt cx="0" cy="0"/>
+        </a:xfrm>
+      </p:grpSpPr>
+      <p:sp>
+        <p:nvSpPr>
+          <p:cNvPr id="2" name="Slide Image Placeholder 1"/>
+          <p:cNvSpPr>
+            <a:spLocks noGrp="1" noRot="1" noChangeAspect="1"/>
+          </p:cNvSpPr>
+          <p:nvPr>
+            <p:ph type="sldImg"/>
+          </p:nvPr>
+        </p:nvSpPr>
+        <p:spPr/>
+      </p:sp>
+      <p:sp>
+        <p:nvSpPr>
+          <p:cNvPr id="3" name="Notes Placeholder 2"/>
+          <p:cNvSpPr>
+            <a:spLocks noGrp="1"/>
+          </p:cNvSpPr>
+          <p:nvPr>
+            <p:ph type="body" idx="1"/>
+          </p:nvPr>
+        </p:nvSpPr>
+        <p:spPr/>
+        <p:txBody>
+          <a:bodyPr/>
+          <a:lstStyle/>
+          <a:p>
+            <a:endParaRPr lang="en-US" dirty="0"/>
+          </a:p>
+        </p:txBody>
+      </p:sp>
+      <p:sp>
+        <p:nvSpPr>
+          <p:cNvPr id="4" name="Slide Number Placeholder 3"/>
+          <p:cNvSpPr>
+            <a:spLocks noGrp="1"/>
+          </p:cNvSpPr>
+          <p:nvPr>
+            <p:ph type="sldNum" sz="quarter" idx="5"/>
+          </p:nvPr>
+        </p:nvSpPr>
+        <p:spPr/>
+        <p:txBody>
+          <a:bodyPr/>
+          <a:lstStyle/>
+          <a:p>
+            <a:fld id="{9765AF27-32A6-4D2B-8C54-2780EFC37AB4}" type="slidenum">
+              <a:rPr lang="en-US" smtClean="0"/>
+              <a:t>15</a:t>
+            </a:fld>
+            <a:endParaRPr lang="en-US"/>
+          </a:p>
+        </p:txBody>
+      </p:sp>
+    </p:spTree>
+    <p:extLst>
+      <p:ext uri="{BB962C8B-B14F-4D97-AF65-F5344CB8AC3E}">
+        <p14:creationId xmlns:p14="http://schemas.microsoft.com/office/powerpoint/2010/main" val="281709076"/>
+      </p:ext>
+    </p:extLst>
+  </p:cSld>
+  <p:clrMapOvr>
+    <a:masterClrMapping/>
+  </p:clrMapOvr>
+</p:notes>
 </file>
 
 <file path=ppt/slideLayouts/slideLayout1.xml><?xml version="1.0" encoding="utf-8"?>
@@ -904,7 +1388,7 @@
             <a:fld id="{3F384AAD-F2F7-440E-A41C-6B3FA172D4A3}" type="datetimeFigureOut">
               <a:rPr lang="en-US" smtClean="0"/>
               <a:pPr/>
-              <a:t>7/8/2025</a:t>
+              <a:t>7/18/2025</a:t>
             </a:fld>
             <a:endParaRPr lang="en-US"/>
           </a:p>
@@ -1069,7 +1553,7 @@
             <a:fld id="{3F384AAD-F2F7-440E-A41C-6B3FA172D4A3}" type="datetimeFigureOut">
               <a:rPr lang="en-US" smtClean="0"/>
               <a:pPr/>
-              <a:t>7/8/2025</a:t>
+              <a:t>7/18/2025</a:t>
             </a:fld>
             <a:endParaRPr lang="en-US"/>
           </a:p>
@@ -1244,7 +1728,7 @@
             <a:fld id="{3F384AAD-F2F7-440E-A41C-6B3FA172D4A3}" type="datetimeFigureOut">
               <a:rPr lang="en-US" smtClean="0"/>
               <a:pPr/>
-              <a:t>7/8/2025</a:t>
+              <a:t>7/18/2025</a:t>
             </a:fld>
             <a:endParaRPr lang="en-US"/>
           </a:p>
@@ -1409,7 +1893,7 @@
             <a:fld id="{3F384AAD-F2F7-440E-A41C-6B3FA172D4A3}" type="datetimeFigureOut">
               <a:rPr lang="en-US" smtClean="0"/>
               <a:pPr/>
-              <a:t>7/8/2025</a:t>
+              <a:t>7/18/2025</a:t>
             </a:fld>
             <a:endParaRPr lang="en-US"/>
           </a:p>
@@ -1651,7 +2135,7 @@
             <a:fld id="{3F384AAD-F2F7-440E-A41C-6B3FA172D4A3}" type="datetimeFigureOut">
               <a:rPr lang="en-US" smtClean="0"/>
               <a:pPr/>
-              <a:t>7/8/2025</a:t>
+              <a:t>7/18/2025</a:t>
             </a:fld>
             <a:endParaRPr lang="en-US"/>
           </a:p>
@@ -1933,7 +2417,7 @@
             <a:fld id="{3F384AAD-F2F7-440E-A41C-6B3FA172D4A3}" type="datetimeFigureOut">
               <a:rPr lang="en-US" smtClean="0"/>
               <a:pPr/>
-              <a:t>7/8/2025</a:t>
+              <a:t>7/18/2025</a:t>
             </a:fld>
             <a:endParaRPr lang="en-US"/>
           </a:p>
@@ -2349,7 +2833,7 @@
             <a:fld id="{3F384AAD-F2F7-440E-A41C-6B3FA172D4A3}" type="datetimeFigureOut">
               <a:rPr lang="en-US" smtClean="0"/>
               <a:pPr/>
-              <a:t>7/8/2025</a:t>
+              <a:t>7/18/2025</a:t>
             </a:fld>
             <a:endParaRPr lang="en-US"/>
           </a:p>
@@ -2463,7 +2947,7 @@
             <a:fld id="{3F384AAD-F2F7-440E-A41C-6B3FA172D4A3}" type="datetimeFigureOut">
               <a:rPr lang="en-US" smtClean="0"/>
               <a:pPr/>
-              <a:t>7/8/2025</a:t>
+              <a:t>7/18/2025</a:t>
             </a:fld>
             <a:endParaRPr lang="en-US"/>
           </a:p>
@@ -2555,7 +3039,7 @@
             <a:fld id="{3F384AAD-F2F7-440E-A41C-6B3FA172D4A3}" type="datetimeFigureOut">
               <a:rPr lang="en-US" smtClean="0"/>
               <a:pPr/>
-              <a:t>7/8/2025</a:t>
+              <a:t>7/18/2025</a:t>
             </a:fld>
             <a:endParaRPr lang="en-US"/>
           </a:p>
@@ -2827,7 +3311,7 @@
             <a:fld id="{3F384AAD-F2F7-440E-A41C-6B3FA172D4A3}" type="datetimeFigureOut">
               <a:rPr lang="en-US" smtClean="0"/>
               <a:pPr/>
-              <a:t>7/8/2025</a:t>
+              <a:t>7/18/2025</a:t>
             </a:fld>
             <a:endParaRPr lang="en-US"/>
           </a:p>
@@ -3076,7 +3560,7 @@
             <a:fld id="{3F384AAD-F2F7-440E-A41C-6B3FA172D4A3}" type="datetimeFigureOut">
               <a:rPr lang="en-US" smtClean="0"/>
               <a:pPr/>
-              <a:t>7/8/2025</a:t>
+              <a:t>7/18/2025</a:t>
             </a:fld>
             <a:endParaRPr lang="en-US"/>
           </a:p>
@@ -3284,7 +3768,7 @@
             <a:fld id="{3F384AAD-F2F7-440E-A41C-6B3FA172D4A3}" type="datetimeFigureOut">
               <a:rPr lang="en-US" smtClean="0"/>
               <a:pPr/>
-              <a:t>7/8/2025</a:t>
+              <a:t>7/18/2025</a:t>
             </a:fld>
             <a:endParaRPr lang="en-US"/>
           </a:p>
@@ -3848,12 +4332,49 @@
           <a:prstGeom prst="straightConnector1">
             <a:avLst/>
           </a:prstGeom>
-          <a:ln>
+          <a:ln w="28575">
             <a:solidFill>
-              <a:srgbClr val="FF0000"/>
+              <a:schemeClr val="accent1"/>
             </a:solidFill>
-            <a:tailEnd type="triangle"/>
+            <a:tailEnd type="arrow"/>
           </a:ln>
+        </p:spPr>
+        <p:style>
+          <a:lnRef idx="1">
+            <a:schemeClr val="accent1"/>
+          </a:lnRef>
+          <a:fillRef idx="0">
+            <a:schemeClr val="accent1"/>
+          </a:fillRef>
+          <a:effectRef idx="0">
+            <a:schemeClr val="accent1"/>
+          </a:effectRef>
+          <a:fontRef idx="minor">
+            <a:schemeClr val="tx1"/>
+          </a:fontRef>
+        </p:style>
+      </p:cxnSp>
+      <p:cxnSp>
+        <p:nvCxnSpPr>
+          <p:cNvPr id="4" name="Straight Connector 3">
+            <a:extLst>
+              <a:ext uri="{FF2B5EF4-FFF2-40B4-BE49-F238E27FC236}">
+                <a16:creationId xmlns:a16="http://schemas.microsoft.com/office/drawing/2014/main" id="{D4D97E3C-8D7F-755B-E041-AF4D2A522FB4}"/>
+              </a:ext>
+            </a:extLst>
+          </p:cNvPr>
+          <p:cNvCxnSpPr/>
+          <p:nvPr/>
+        </p:nvCxnSpPr>
+        <p:spPr>
+          <a:xfrm>
+            <a:off x="5279136" y="1938528"/>
+            <a:ext cx="0" cy="1956816"/>
+          </a:xfrm>
+          <a:prstGeom prst="line">
+            <a:avLst/>
+          </a:prstGeom>
+          <a:ln w="28575"/>
         </p:spPr>
         <p:style>
           <a:lnRef idx="1">
@@ -4447,12 +4968,85 @@
           <a:chExt cx="0" cy="0"/>
         </a:xfrm>
       </p:grpSpPr>
+      <p:cxnSp>
+        <p:nvCxnSpPr>
+          <p:cNvPr id="4" name="Straight Connector 3">
+            <a:extLst>
+              <a:ext uri="{FF2B5EF4-FFF2-40B4-BE49-F238E27FC236}">
+                <a16:creationId xmlns:a16="http://schemas.microsoft.com/office/drawing/2014/main" id="{ACFF82DA-979A-3AFB-D691-10055ACDC352}"/>
+              </a:ext>
+            </a:extLst>
+          </p:cNvPr>
+          <p:cNvCxnSpPr/>
+          <p:nvPr/>
+        </p:nvCxnSpPr>
+        <p:spPr>
+          <a:xfrm>
+            <a:off x="4087368" y="2953512"/>
+            <a:ext cx="2377440" cy="0"/>
+          </a:xfrm>
+          <a:prstGeom prst="line">
+            <a:avLst/>
+          </a:prstGeom>
+        </p:spPr>
+        <p:style>
+          <a:lnRef idx="1">
+            <a:schemeClr val="accent1"/>
+          </a:lnRef>
+          <a:fillRef idx="0">
+            <a:schemeClr val="accent1"/>
+          </a:fillRef>
+          <a:effectRef idx="0">
+            <a:schemeClr val="accent1"/>
+          </a:effectRef>
+          <a:fontRef idx="minor">
+            <a:schemeClr val="tx1"/>
+          </a:fontRef>
+        </p:style>
+      </p:cxnSp>
+      <p:cxnSp>
+        <p:nvCxnSpPr>
+          <p:cNvPr id="7" name="Straight Connector 6">
+            <a:extLst>
+              <a:ext uri="{FF2B5EF4-FFF2-40B4-BE49-F238E27FC236}">
+                <a16:creationId xmlns:a16="http://schemas.microsoft.com/office/drawing/2014/main" id="{6FBF6BC9-6961-A8F3-984A-481B042B1B81}"/>
+              </a:ext>
+            </a:extLst>
+          </p:cNvPr>
+          <p:cNvCxnSpPr/>
+          <p:nvPr/>
+        </p:nvCxnSpPr>
+        <p:spPr>
+          <a:xfrm flipV="1">
+            <a:off x="4087368" y="2953512"/>
+            <a:ext cx="2377440" cy="6477"/>
+          </a:xfrm>
+          <a:prstGeom prst="line">
+            <a:avLst/>
+          </a:prstGeom>
+          <a:ln w="38100"/>
+        </p:spPr>
+        <p:style>
+          <a:lnRef idx="1">
+            <a:schemeClr val="accent1"/>
+          </a:lnRef>
+          <a:fillRef idx="0">
+            <a:schemeClr val="accent1"/>
+          </a:fillRef>
+          <a:effectRef idx="0">
+            <a:schemeClr val="accent1"/>
+          </a:effectRef>
+          <a:fontRef idx="minor">
+            <a:schemeClr val="tx1"/>
+          </a:fontRef>
+        </p:style>
+      </p:cxnSp>
       <p:pic>
         <p:nvPicPr>
-          <p:cNvPr id="5" name="Picture 4">
+          <p:cNvPr id="14" name="Picture 13">
             <a:extLst>
               <a:ext uri="{FF2B5EF4-FFF2-40B4-BE49-F238E27FC236}">
-                <a16:creationId xmlns:a16="http://schemas.microsoft.com/office/drawing/2014/main" id="{E8B8C2B6-2DC3-3AF5-4331-B1B2288CFE46}"/>
+                <a16:creationId xmlns:a16="http://schemas.microsoft.com/office/drawing/2014/main" id="{8E9D90FE-9859-9131-6FEF-9302CAFC1003}"/>
               </a:ext>
             </a:extLst>
           </p:cNvPr>
@@ -4462,14 +5056,14 @@
           <p:nvPr/>
         </p:nvPicPr>
         <p:blipFill>
-          <a:blip r:embed="rId2"/>
+          <a:blip r:embed="rId3"/>
           <a:stretch>
             <a:fillRect/>
           </a:stretch>
         </p:blipFill>
         <p:spPr>
           <a:xfrm>
-            <a:off x="909619" y="990600"/>
+            <a:off x="1062019" y="1143000"/>
             <a:ext cx="7196007" cy="4791075"/>
           </a:xfrm>
           <a:prstGeom prst="rect">
@@ -4479,10 +5073,83 @@
       </p:pic>
       <p:cxnSp>
         <p:nvCxnSpPr>
-          <p:cNvPr id="2" name="Straight Arrow Connector 1">
+          <p:cNvPr id="15" name="Straight Connector 14">
             <a:extLst>
               <a:ext uri="{FF2B5EF4-FFF2-40B4-BE49-F238E27FC236}">
-                <a16:creationId xmlns:a16="http://schemas.microsoft.com/office/drawing/2014/main" id="{2B34615C-03A8-8887-A787-5DFCE08ABDB9}"/>
+                <a16:creationId xmlns:a16="http://schemas.microsoft.com/office/drawing/2014/main" id="{7CC3A4AD-E3C7-1F8F-8E47-BEF3A11FA1EB}"/>
+              </a:ext>
+            </a:extLst>
+          </p:cNvPr>
+          <p:cNvCxnSpPr/>
+          <p:nvPr/>
+        </p:nvCxnSpPr>
+        <p:spPr>
+          <a:xfrm>
+            <a:off x="4239768" y="3105912"/>
+            <a:ext cx="2377440" cy="0"/>
+          </a:xfrm>
+          <a:prstGeom prst="line">
+            <a:avLst/>
+          </a:prstGeom>
+        </p:spPr>
+        <p:style>
+          <a:lnRef idx="1">
+            <a:schemeClr val="accent1"/>
+          </a:lnRef>
+          <a:fillRef idx="0">
+            <a:schemeClr val="accent1"/>
+          </a:fillRef>
+          <a:effectRef idx="0">
+            <a:schemeClr val="accent1"/>
+          </a:effectRef>
+          <a:fontRef idx="minor">
+            <a:schemeClr val="tx1"/>
+          </a:fontRef>
+        </p:style>
+      </p:cxnSp>
+      <p:cxnSp>
+        <p:nvCxnSpPr>
+          <p:cNvPr id="16" name="Straight Connector 15">
+            <a:extLst>
+              <a:ext uri="{FF2B5EF4-FFF2-40B4-BE49-F238E27FC236}">
+                <a16:creationId xmlns:a16="http://schemas.microsoft.com/office/drawing/2014/main" id="{9CB70B8F-6FCD-7EBD-F47D-134E1E54C66E}"/>
+              </a:ext>
+            </a:extLst>
+          </p:cNvPr>
+          <p:cNvCxnSpPr/>
+          <p:nvPr/>
+        </p:nvCxnSpPr>
+        <p:spPr>
+          <a:xfrm flipV="1">
+            <a:off x="4239768" y="3105912"/>
+            <a:ext cx="2377440" cy="6477"/>
+          </a:xfrm>
+          <a:prstGeom prst="line">
+            <a:avLst/>
+          </a:prstGeom>
+          <a:ln w="38100"/>
+        </p:spPr>
+        <p:style>
+          <a:lnRef idx="1">
+            <a:schemeClr val="accent1"/>
+          </a:lnRef>
+          <a:fillRef idx="0">
+            <a:schemeClr val="accent1"/>
+          </a:fillRef>
+          <a:effectRef idx="0">
+            <a:schemeClr val="accent1"/>
+          </a:effectRef>
+          <a:fontRef idx="minor">
+            <a:schemeClr val="tx1"/>
+          </a:fontRef>
+        </p:style>
+      </p:cxnSp>
+      <p:cxnSp>
+        <p:nvCxnSpPr>
+          <p:cNvPr id="17" name="Straight Arrow Connector 16">
+            <a:extLst>
+              <a:ext uri="{FF2B5EF4-FFF2-40B4-BE49-F238E27FC236}">
+                <a16:creationId xmlns:a16="http://schemas.microsoft.com/office/drawing/2014/main" id="{51F59622-C043-2EC3-B061-4FFA439E6FEB}"/>
               </a:ext>
             </a:extLst>
           </p:cNvPr>
@@ -4493,19 +5160,17 @@
         </p:nvCxnSpPr>
         <p:spPr>
           <a:xfrm>
-            <a:off x="4896231" y="2950845"/>
+            <a:off x="5048631" y="3112389"/>
             <a:ext cx="438150" cy="0"/>
           </a:xfrm>
           <a:prstGeom prst="straightConnector1">
             <a:avLst/>
           </a:prstGeom>
-          <a:ln w="6350">
+          <a:ln w="19050">
             <a:solidFill>
-              <a:schemeClr val="accent3">
-                <a:lumMod val="75000"/>
-              </a:schemeClr>
+              <a:schemeClr val="accent1"/>
             </a:solidFill>
-            <a:tailEnd type="triangle"/>
+            <a:tailEnd type="arrow" w="lg" len="lg"/>
           </a:ln>
         </p:spPr>
         <p:style>
@@ -5493,7 +6158,7 @@
             <a:solidFill>
               <a:srgbClr val="FF0000"/>
             </a:solidFill>
-            <a:tailEnd type="triangle"/>
+            <a:tailEnd type="arrow" w="lg" len="lg"/>
           </a:ln>
         </p:spPr>
         <p:style>
@@ -20501,4 +21166,319 @@
   <a:objectDefaults/>
   <a:extraClrSchemeLst/>
 </a:theme>
+</file>
+
+<file path=ppt/theme/theme2.xml><?xml version="1.0" encoding="utf-8"?>
+<a:theme xmlns:a="http://schemas.openxmlformats.org/drawingml/2006/main" name="Office Theme">
+  <a:themeElements>
+    <a:clrScheme name="Office">
+      <a:dk1>
+        <a:sysClr val="windowText" lastClr="000000"/>
+      </a:dk1>
+      <a:lt1>
+        <a:sysClr val="window" lastClr="FFFFFF"/>
+      </a:lt1>
+      <a:dk2>
+        <a:srgbClr val="0E2841"/>
+      </a:dk2>
+      <a:lt2>
+        <a:srgbClr val="E8E8E8"/>
+      </a:lt2>
+      <a:accent1>
+        <a:srgbClr val="156082"/>
+      </a:accent1>
+      <a:accent2>
+        <a:srgbClr val="E97132"/>
+      </a:accent2>
+      <a:accent3>
+        <a:srgbClr val="196B24"/>
+      </a:accent3>
+      <a:accent4>
+        <a:srgbClr val="0F9ED5"/>
+      </a:accent4>
+      <a:accent5>
+        <a:srgbClr val="A02B93"/>
+      </a:accent5>
+      <a:accent6>
+        <a:srgbClr val="4EA72E"/>
+      </a:accent6>
+      <a:hlink>
+        <a:srgbClr val="467886"/>
+      </a:hlink>
+      <a:folHlink>
+        <a:srgbClr val="96607D"/>
+      </a:folHlink>
+    </a:clrScheme>
+    <a:fontScheme name="Office">
+      <a:majorFont>
+        <a:latin typeface="Aptos Display" panose="02110004020202020204"/>
+        <a:ea typeface=""/>
+        <a:cs typeface=""/>
+        <a:font script="Jpan" typeface="游ゴシック Light"/>
+        <a:font script="Hang" typeface="맑은 고딕"/>
+        <a:font script="Hans" typeface="等线 Light"/>
+        <a:font script="Hant" typeface="新細明體"/>
+        <a:font script="Arab" typeface="Times New Roman"/>
+        <a:font script="Hebr" typeface="Times New Roman"/>
+        <a:font script="Thai" typeface="Angsana New"/>
+        <a:font script="Ethi" typeface="Nyala"/>
+        <a:font script="Beng" typeface="Vrinda"/>
+        <a:font script="Gujr" typeface="Shruti"/>
+        <a:font script="Khmr" typeface="MoolBoran"/>
+        <a:font script="Knda" typeface="Tunga"/>
+        <a:font script="Guru" typeface="Raavi"/>
+        <a:font script="Cans" typeface="Euphemia"/>
+        <a:font script="Cher" typeface="Plantagenet Cherokee"/>
+        <a:font script="Yiii" typeface="Microsoft Yi Baiti"/>
+        <a:font script="Tibt" typeface="Microsoft Himalaya"/>
+        <a:font script="Thaa" typeface="MV Boli"/>
+        <a:font script="Deva" typeface="Mangal"/>
+        <a:font script="Telu" typeface="Gautami"/>
+        <a:font script="Taml" typeface="Latha"/>
+        <a:font script="Syrc" typeface="Estrangelo Edessa"/>
+        <a:font script="Orya" typeface="Kalinga"/>
+        <a:font script="Mlym" typeface="Kartika"/>
+        <a:font script="Laoo" typeface="DokChampa"/>
+        <a:font script="Sinh" typeface="Iskoola Pota"/>
+        <a:font script="Mong" typeface="Mongolian Baiti"/>
+        <a:font script="Viet" typeface="Times New Roman"/>
+        <a:font script="Uigh" typeface="Microsoft Uighur"/>
+        <a:font script="Geor" typeface="Sylfaen"/>
+        <a:font script="Armn" typeface="Arial"/>
+        <a:font script="Bugi" typeface="Leelawadee UI"/>
+        <a:font script="Bopo" typeface="Microsoft JhengHei"/>
+        <a:font script="Java" typeface="Javanese Text"/>
+        <a:font script="Lisu" typeface="Segoe UI"/>
+        <a:font script="Mymr" typeface="Myanmar Text"/>
+        <a:font script="Nkoo" typeface="Ebrima"/>
+        <a:font script="Olck" typeface="Nirmala UI"/>
+        <a:font script="Osma" typeface="Ebrima"/>
+        <a:font script="Phag" typeface="Phagspa"/>
+        <a:font script="Syrn" typeface="Estrangelo Edessa"/>
+        <a:font script="Syrj" typeface="Estrangelo Edessa"/>
+        <a:font script="Syre" typeface="Estrangelo Edessa"/>
+        <a:font script="Sora" typeface="Nirmala UI"/>
+        <a:font script="Tale" typeface="Microsoft Tai Le"/>
+        <a:font script="Talu" typeface="Microsoft New Tai Lue"/>
+        <a:font script="Tfng" typeface="Ebrima"/>
+      </a:majorFont>
+      <a:minorFont>
+        <a:latin typeface="Aptos" panose="02110004020202020204"/>
+        <a:ea typeface=""/>
+        <a:cs typeface=""/>
+        <a:font script="Jpan" typeface="游ゴシック"/>
+        <a:font script="Hang" typeface="맑은 고딕"/>
+        <a:font script="Hans" typeface="等线"/>
+        <a:font script="Hant" typeface="新細明體"/>
+        <a:font script="Arab" typeface="Arial"/>
+        <a:font script="Hebr" typeface="Arial"/>
+        <a:font script="Thai" typeface="Cordia New"/>
+        <a:font script="Ethi" typeface="Nyala"/>
+        <a:font script="Beng" typeface="Vrinda"/>
+        <a:font script="Gujr" typeface="Shruti"/>
+        <a:font script="Khmr" typeface="DaunPenh"/>
+        <a:font script="Knda" typeface="Tunga"/>
+        <a:font script="Guru" typeface="Raavi"/>
+        <a:font script="Cans" typeface="Euphemia"/>
+        <a:font script="Cher" typeface="Plantagenet Cherokee"/>
+        <a:font script="Yiii" typeface="Microsoft Yi Baiti"/>
+        <a:font script="Tibt" typeface="Microsoft Himalaya"/>
+        <a:font script="Thaa" typeface="MV Boli"/>
+        <a:font script="Deva" typeface="Mangal"/>
+        <a:font script="Telu" typeface="Gautami"/>
+        <a:font script="Taml" typeface="Latha"/>
+        <a:font script="Syrc" typeface="Estrangelo Edessa"/>
+        <a:font script="Orya" typeface="Kalinga"/>
+        <a:font script="Mlym" typeface="Kartika"/>
+        <a:font script="Laoo" typeface="DokChampa"/>
+        <a:font script="Sinh" typeface="Iskoola Pota"/>
+        <a:font script="Mong" typeface="Mongolian Baiti"/>
+        <a:font script="Viet" typeface="Arial"/>
+        <a:font script="Uigh" typeface="Microsoft Uighur"/>
+        <a:font script="Geor" typeface="Sylfaen"/>
+        <a:font script="Armn" typeface="Arial"/>
+        <a:font script="Bugi" typeface="Leelawadee UI"/>
+        <a:font script="Bopo" typeface="Microsoft JhengHei"/>
+        <a:font script="Java" typeface="Javanese Text"/>
+        <a:font script="Lisu" typeface="Segoe UI"/>
+        <a:font script="Mymr" typeface="Myanmar Text"/>
+        <a:font script="Nkoo" typeface="Ebrima"/>
+        <a:font script="Olck" typeface="Nirmala UI"/>
+        <a:font script="Osma" typeface="Ebrima"/>
+        <a:font script="Phag" typeface="Phagspa"/>
+        <a:font script="Syrn" typeface="Estrangelo Edessa"/>
+        <a:font script="Syrj" typeface="Estrangelo Edessa"/>
+        <a:font script="Syre" typeface="Estrangelo Edessa"/>
+        <a:font script="Sora" typeface="Nirmala UI"/>
+        <a:font script="Tale" typeface="Microsoft Tai Le"/>
+        <a:font script="Talu" typeface="Microsoft New Tai Lue"/>
+        <a:font script="Tfng" typeface="Ebrima"/>
+      </a:minorFont>
+    </a:fontScheme>
+    <a:fmtScheme name="Office">
+      <a:fillStyleLst>
+        <a:solidFill>
+          <a:schemeClr val="phClr"/>
+        </a:solidFill>
+        <a:gradFill rotWithShape="1">
+          <a:gsLst>
+            <a:gs pos="0">
+              <a:schemeClr val="phClr">
+                <a:lumMod val="110000"/>
+                <a:satMod val="105000"/>
+                <a:tint val="67000"/>
+              </a:schemeClr>
+            </a:gs>
+            <a:gs pos="50000">
+              <a:schemeClr val="phClr">
+                <a:lumMod val="105000"/>
+                <a:satMod val="103000"/>
+                <a:tint val="73000"/>
+              </a:schemeClr>
+            </a:gs>
+            <a:gs pos="100000">
+              <a:schemeClr val="phClr">
+                <a:lumMod val="105000"/>
+                <a:satMod val="109000"/>
+                <a:tint val="81000"/>
+              </a:schemeClr>
+            </a:gs>
+          </a:gsLst>
+          <a:lin ang="5400000" scaled="0"/>
+        </a:gradFill>
+        <a:gradFill rotWithShape="1">
+          <a:gsLst>
+            <a:gs pos="0">
+              <a:schemeClr val="phClr">
+                <a:satMod val="103000"/>
+                <a:lumMod val="102000"/>
+                <a:tint val="94000"/>
+              </a:schemeClr>
+            </a:gs>
+            <a:gs pos="50000">
+              <a:schemeClr val="phClr">
+                <a:satMod val="110000"/>
+                <a:lumMod val="100000"/>
+                <a:shade val="100000"/>
+              </a:schemeClr>
+            </a:gs>
+            <a:gs pos="100000">
+              <a:schemeClr val="phClr">
+                <a:lumMod val="99000"/>
+                <a:satMod val="120000"/>
+                <a:shade val="78000"/>
+              </a:schemeClr>
+            </a:gs>
+          </a:gsLst>
+          <a:lin ang="5400000" scaled="0"/>
+        </a:gradFill>
+      </a:fillStyleLst>
+      <a:lnStyleLst>
+        <a:ln w="12700" cap="flat" cmpd="sng" algn="ctr">
+          <a:solidFill>
+            <a:schemeClr val="phClr"/>
+          </a:solidFill>
+          <a:prstDash val="solid"/>
+          <a:miter lim="800000"/>
+        </a:ln>
+        <a:ln w="19050" cap="flat" cmpd="sng" algn="ctr">
+          <a:solidFill>
+            <a:schemeClr val="phClr"/>
+          </a:solidFill>
+          <a:prstDash val="solid"/>
+          <a:miter lim="800000"/>
+        </a:ln>
+        <a:ln w="25400" cap="flat" cmpd="sng" algn="ctr">
+          <a:solidFill>
+            <a:schemeClr val="phClr"/>
+          </a:solidFill>
+          <a:prstDash val="solid"/>
+          <a:miter lim="800000"/>
+        </a:ln>
+      </a:lnStyleLst>
+      <a:effectStyleLst>
+        <a:effectStyle>
+          <a:effectLst/>
+        </a:effectStyle>
+        <a:effectStyle>
+          <a:effectLst/>
+        </a:effectStyle>
+        <a:effectStyle>
+          <a:effectLst>
+            <a:outerShdw blurRad="57150" dist="19050" dir="5400000" algn="ctr" rotWithShape="0">
+              <a:srgbClr val="000000">
+                <a:alpha val="63000"/>
+              </a:srgbClr>
+            </a:outerShdw>
+          </a:effectLst>
+        </a:effectStyle>
+      </a:effectStyleLst>
+      <a:bgFillStyleLst>
+        <a:solidFill>
+          <a:schemeClr val="phClr"/>
+        </a:solidFill>
+        <a:solidFill>
+          <a:schemeClr val="phClr">
+            <a:tint val="95000"/>
+            <a:satMod val="170000"/>
+          </a:schemeClr>
+        </a:solidFill>
+        <a:gradFill rotWithShape="1">
+          <a:gsLst>
+            <a:gs pos="0">
+              <a:schemeClr val="phClr">
+                <a:tint val="93000"/>
+                <a:satMod val="150000"/>
+                <a:shade val="98000"/>
+                <a:lumMod val="102000"/>
+              </a:schemeClr>
+            </a:gs>
+            <a:gs pos="50000">
+              <a:schemeClr val="phClr">
+                <a:tint val="98000"/>
+                <a:satMod val="130000"/>
+                <a:shade val="90000"/>
+                <a:lumMod val="103000"/>
+              </a:schemeClr>
+            </a:gs>
+            <a:gs pos="100000">
+              <a:schemeClr val="phClr">
+                <a:shade val="63000"/>
+                <a:satMod val="120000"/>
+              </a:schemeClr>
+            </a:gs>
+          </a:gsLst>
+          <a:lin ang="5400000" scaled="0"/>
+        </a:gradFill>
+      </a:bgFillStyleLst>
+    </a:fmtScheme>
+  </a:themeElements>
+  <a:objectDefaults>
+    <a:lnDef>
+      <a:spPr/>
+      <a:bodyPr/>
+      <a:lstStyle/>
+      <a:style>
+        <a:lnRef idx="2">
+          <a:schemeClr val="accent1"/>
+        </a:lnRef>
+        <a:fillRef idx="0">
+          <a:schemeClr val="accent1"/>
+        </a:fillRef>
+        <a:effectRef idx="1">
+          <a:schemeClr val="accent1"/>
+        </a:effectRef>
+        <a:fontRef idx="minor">
+          <a:schemeClr val="tx1"/>
+        </a:fontRef>
+      </a:style>
+    </a:lnDef>
+  </a:objectDefaults>
+  <a:extraClrSchemeLst/>
+  <a:extLst>
+    <a:ext uri="{05A4C25C-085E-4340-85A3-A5531E510DB2}">
+      <thm15:themeFamily xmlns:thm15="http://schemas.microsoft.com/office/thememl/2012/main" name="Office Theme" id="{2E142A2C-CD16-42D6-873A-C26D2A0506FA}" vid="{1BDDFF52-6CD6-40A5-AB3C-68EB2F1E4D0A}"/>
+    </a:ext>
+  </a:extLst>
+</a:theme>
 </file>
</xml_diff>

<commit_message>
updates through chapter 36
</commit_message>
<xml_diff>
--- a/Lecture_Slides/PH 123 Lecture 35.pptx
+++ b/Lecture_Slides/PH 123 Lecture 35.pptx
@@ -175,7 +175,7 @@
 <file path=ppt/revisionInfo.xml><?xml version="1.0" encoding="utf-8"?>
 <p1510:revInfo xmlns:a="http://schemas.openxmlformats.org/drawingml/2006/main" xmlns:r="http://schemas.openxmlformats.org/officeDocument/2006/relationships" xmlns:p1510="http://schemas.microsoft.com/office/powerpoint/2015/10/main">
   <p1510:revLst>
-    <p1510:client id="{002822DB-EE53-4F2A-8F03-1C9D4C4542CA}" v="38" dt="2025-07-18T17:51:42.576"/>
+    <p1510:client id="{FAB77558-8216-4B44-BA84-D4E5472E7BA5}" v="3" dt="2026-03-27T17:11:35.071"/>
   </p1510:revLst>
 </p1510:revInfo>
 </file>
@@ -183,592 +183,57 @@
 <file path=ppt/changesInfos/changesInfo1.xml><?xml version="1.0" encoding="utf-8"?>
 <pc:chgInfo xmlns:a="http://schemas.openxmlformats.org/drawingml/2006/main" xmlns:r="http://schemas.openxmlformats.org/officeDocument/2006/relationships" xmlns:ac="http://schemas.microsoft.com/office/drawing/2013/main/command" xmlns:pc="http://schemas.microsoft.com/office/powerpoint/2013/main/command">
   <pc:docChgLst>
-    <pc:chgData name="Lines, Todd" userId="afaf7c3a-e8aa-4568-882a-02ad8f9e19b0" providerId="ADAL" clId="{002822DB-EE53-4F2A-8F03-1C9D4C4542CA}"/>
-    <pc:docChg chg="custSel addSld delSld modSld sldOrd">
-      <pc:chgData name="Lines, Todd" userId="afaf7c3a-e8aa-4568-882a-02ad8f9e19b0" providerId="ADAL" clId="{002822DB-EE53-4F2A-8F03-1C9D4C4542CA}" dt="2025-07-18T17:51:46.494" v="641" actId="21"/>
+    <pc:chgData name="Lines, Todd" userId="afaf7c3a-e8aa-4568-882a-02ad8f9e19b0" providerId="ADAL" clId="{5FF5AC1B-ABA9-43D7-A1E3-2D92732CD6E2}"/>
+    <pc:docChg chg="custSel modSld">
+      <pc:chgData name="Lines, Todd" userId="afaf7c3a-e8aa-4568-882a-02ad8f9e19b0" providerId="ADAL" clId="{5FF5AC1B-ABA9-43D7-A1E3-2D92732CD6E2}" dt="2026-03-27T17:11:39.022" v="6" actId="21"/>
       <pc:docMkLst>
         <pc:docMk/>
       </pc:docMkLst>
-      <pc:sldChg chg="modSp new mod">
-        <pc:chgData name="Lines, Todd" userId="afaf7c3a-e8aa-4568-882a-02ad8f9e19b0" providerId="ADAL" clId="{002822DB-EE53-4F2A-8F03-1C9D4C4542CA}" dt="2025-07-03T22:24:01.047" v="10" actId="20577"/>
-        <pc:sldMkLst>
-          <pc:docMk/>
-          <pc:sldMk cId="1648075400" sldId="281"/>
-        </pc:sldMkLst>
-        <pc:spChg chg="mod">
-          <ac:chgData name="Lines, Todd" userId="afaf7c3a-e8aa-4568-882a-02ad8f9e19b0" providerId="ADAL" clId="{002822DB-EE53-4F2A-8F03-1C9D4C4542CA}" dt="2025-07-03T22:24:01.047" v="10" actId="20577"/>
-          <ac:spMkLst>
-            <pc:docMk/>
-            <pc:sldMk cId="1648075400" sldId="281"/>
-            <ac:spMk id="2" creationId="{AE56B6F5-A6EB-37BB-85A9-10085F3A30B5}"/>
-          </ac:spMkLst>
-        </pc:spChg>
-      </pc:sldChg>
-      <pc:sldChg chg="addSp delSp modSp new mod modClrScheme chgLayout">
-        <pc:chgData name="Lines, Todd" userId="afaf7c3a-e8aa-4568-882a-02ad8f9e19b0" providerId="ADAL" clId="{002822DB-EE53-4F2A-8F03-1C9D4C4542CA}" dt="2025-07-03T22:24:11.080" v="15" actId="20577"/>
-        <pc:sldMkLst>
-          <pc:docMk/>
-          <pc:sldMk cId="255763619" sldId="282"/>
-        </pc:sldMkLst>
-        <pc:spChg chg="add mod ord">
-          <ac:chgData name="Lines, Todd" userId="afaf7c3a-e8aa-4568-882a-02ad8f9e19b0" providerId="ADAL" clId="{002822DB-EE53-4F2A-8F03-1C9D4C4542CA}" dt="2025-07-03T22:24:11.080" v="15" actId="20577"/>
-          <ac:spMkLst>
-            <pc:docMk/>
-            <pc:sldMk cId="255763619" sldId="282"/>
-            <ac:spMk id="4" creationId="{67BC53A5-796C-A723-6550-FECB380815A4}"/>
-          </ac:spMkLst>
-        </pc:spChg>
-        <pc:spChg chg="add mod ord">
-          <ac:chgData name="Lines, Todd" userId="afaf7c3a-e8aa-4568-882a-02ad8f9e19b0" providerId="ADAL" clId="{002822DB-EE53-4F2A-8F03-1C9D4C4542CA}" dt="2025-07-03T22:24:08.721" v="12" actId="700"/>
-          <ac:spMkLst>
-            <pc:docMk/>
-            <pc:sldMk cId="255763619" sldId="282"/>
-            <ac:spMk id="5" creationId="{3D4F83FA-4E9E-5E98-6273-B37625F4668B}"/>
-          </ac:spMkLst>
-        </pc:spChg>
-      </pc:sldChg>
-      <pc:sldChg chg="add del">
-        <pc:chgData name="Lines, Todd" userId="afaf7c3a-e8aa-4568-882a-02ad8f9e19b0" providerId="ADAL" clId="{002822DB-EE53-4F2A-8F03-1C9D4C4542CA}" dt="2025-07-03T22:41:58.432" v="69" actId="47"/>
-        <pc:sldMkLst>
-          <pc:docMk/>
-          <pc:sldMk cId="3786188879" sldId="283"/>
-        </pc:sldMkLst>
-      </pc:sldChg>
-      <pc:sldChg chg="addSp delSp modSp new mod">
-        <pc:chgData name="Lines, Todd" userId="afaf7c3a-e8aa-4568-882a-02ad8f9e19b0" providerId="ADAL" clId="{002822DB-EE53-4F2A-8F03-1C9D4C4542CA}" dt="2025-07-08T19:12:43.486" v="565" actId="21"/>
-        <pc:sldMkLst>
-          <pc:docMk/>
-          <pc:sldMk cId="2610071715" sldId="284"/>
-        </pc:sldMkLst>
-        <pc:picChg chg="add mod">
-          <ac:chgData name="Lines, Todd" userId="afaf7c3a-e8aa-4568-882a-02ad8f9e19b0" providerId="ADAL" clId="{002822DB-EE53-4F2A-8F03-1C9D4C4542CA}" dt="2025-07-03T22:34:54.038" v="27" actId="1076"/>
-          <ac:picMkLst>
-            <pc:docMk/>
-            <pc:sldMk cId="2610071715" sldId="284"/>
-            <ac:picMk id="5" creationId="{7C50B44E-422D-0F5E-1EA7-B9FCC089D53D}"/>
-          </ac:picMkLst>
-        </pc:picChg>
-        <pc:cxnChg chg="add mod">
-          <ac:chgData name="Lines, Todd" userId="afaf7c3a-e8aa-4568-882a-02ad8f9e19b0" providerId="ADAL" clId="{002822DB-EE53-4F2A-8F03-1C9D4C4542CA}" dt="2025-07-08T19:12:28.144" v="563" actId="1076"/>
-          <ac:cxnSpMkLst>
-            <pc:docMk/>
-            <pc:sldMk cId="2610071715" sldId="284"/>
-            <ac:cxnSpMk id="2" creationId="{1CA90B52-F499-88B4-8BE1-FD851213A876}"/>
-          </ac:cxnSpMkLst>
-        </pc:cxnChg>
-      </pc:sldChg>
-      <pc:sldChg chg="delSp modSp add del mod">
-        <pc:chgData name="Lines, Todd" userId="afaf7c3a-e8aa-4568-882a-02ad8f9e19b0" providerId="ADAL" clId="{002822DB-EE53-4F2A-8F03-1C9D4C4542CA}" dt="2025-07-03T22:41:58.432" v="69" actId="47"/>
-        <pc:sldMkLst>
-          <pc:docMk/>
-          <pc:sldMk cId="0" sldId="285"/>
-        </pc:sldMkLst>
-      </pc:sldChg>
-      <pc:sldChg chg="add del">
-        <pc:chgData name="Lines, Todd" userId="afaf7c3a-e8aa-4568-882a-02ad8f9e19b0" providerId="ADAL" clId="{002822DB-EE53-4F2A-8F03-1C9D4C4542CA}" dt="2025-07-03T22:41:58.432" v="69" actId="47"/>
-        <pc:sldMkLst>
-          <pc:docMk/>
-          <pc:sldMk cId="0" sldId="340"/>
-        </pc:sldMkLst>
-      </pc:sldChg>
-      <pc:sldChg chg="add">
-        <pc:chgData name="Lines, Todd" userId="afaf7c3a-e8aa-4568-882a-02ad8f9e19b0" providerId="ADAL" clId="{002822DB-EE53-4F2A-8F03-1C9D4C4542CA}" dt="2025-07-03T22:34:21.323" v="22"/>
-        <pc:sldMkLst>
-          <pc:docMk/>
-          <pc:sldMk cId="0" sldId="465"/>
-        </pc:sldMkLst>
-      </pc:sldChg>
-      <pc:sldChg chg="addSp delSp modSp new mod">
-        <pc:chgData name="Lines, Todd" userId="afaf7c3a-e8aa-4568-882a-02ad8f9e19b0" providerId="ADAL" clId="{002822DB-EE53-4F2A-8F03-1C9D4C4542CA}" dt="2025-07-18T17:45:09.371" v="601" actId="21"/>
+      <pc:sldChg chg="delSp modSp mod">
+        <pc:chgData name="Lines, Todd" userId="afaf7c3a-e8aa-4568-882a-02ad8f9e19b0" providerId="ADAL" clId="{5FF5AC1B-ABA9-43D7-A1E3-2D92732CD6E2}" dt="2026-03-27T17:11:39.022" v="6" actId="21"/>
         <pc:sldMkLst>
           <pc:docMk/>
           <pc:sldMk cId="975446107" sldId="466"/>
         </pc:sldMkLst>
         <pc:picChg chg="del mod">
-          <ac:chgData name="Lines, Todd" userId="afaf7c3a-e8aa-4568-882a-02ad8f9e19b0" providerId="ADAL" clId="{002822DB-EE53-4F2A-8F03-1C9D4C4542CA}" dt="2025-07-18T17:45:09.371" v="601" actId="21"/>
+          <ac:chgData name="Lines, Todd" userId="afaf7c3a-e8aa-4568-882a-02ad8f9e19b0" providerId="ADAL" clId="{5FF5AC1B-ABA9-43D7-A1E3-2D92732CD6E2}" dt="2026-03-27T17:11:39.022" v="6" actId="21"/>
           <ac:picMkLst>
             <pc:docMk/>
             <pc:sldMk cId="975446107" sldId="466"/>
-            <ac:picMk id="5" creationId="{2DE00E35-56C9-A012-58D0-D2C3711FCD96}"/>
+            <ac:picMk id="3" creationId="{D5965416-94D8-7644-1F0C-AB06DC5B93C4}"/>
           </ac:picMkLst>
         </pc:picChg>
-        <pc:picChg chg="add mod">
-          <ac:chgData name="Lines, Todd" userId="afaf7c3a-e8aa-4568-882a-02ad8f9e19b0" providerId="ADAL" clId="{002822DB-EE53-4F2A-8F03-1C9D4C4542CA}" dt="2025-07-08T19:15:06.698" v="572" actId="1037"/>
-          <ac:picMkLst>
-            <pc:docMk/>
-            <pc:sldMk cId="975446107" sldId="466"/>
-            <ac:picMk id="7" creationId="{6F3EB732-A7A6-1C91-AB4F-AB9333387F6C}"/>
-          </ac:picMkLst>
-        </pc:picChg>
-        <pc:cxnChg chg="add mod">
-          <ac:chgData name="Lines, Todd" userId="afaf7c3a-e8aa-4568-882a-02ad8f9e19b0" providerId="ADAL" clId="{002822DB-EE53-4F2A-8F03-1C9D4C4542CA}" dt="2025-07-18T17:44:53.901" v="599" actId="692"/>
-          <ac:cxnSpMkLst>
-            <pc:docMk/>
-            <pc:sldMk cId="975446107" sldId="466"/>
-            <ac:cxnSpMk id="2" creationId="{0D1BAB16-90DD-3275-B8BF-0A11B1D71F90}"/>
-          </ac:cxnSpMkLst>
-        </pc:cxnChg>
-        <pc:cxnChg chg="add mod">
-          <ac:chgData name="Lines, Todd" userId="afaf7c3a-e8aa-4568-882a-02ad8f9e19b0" providerId="ADAL" clId="{002822DB-EE53-4F2A-8F03-1C9D4C4542CA}" dt="2025-07-18T17:44:23.410" v="596" actId="1582"/>
-          <ac:cxnSpMkLst>
-            <pc:docMk/>
-            <pc:sldMk cId="975446107" sldId="466"/>
-            <ac:cxnSpMk id="4" creationId="{D4D97E3C-8D7F-755B-E041-AF4D2A522FB4}"/>
-          </ac:cxnSpMkLst>
-        </pc:cxnChg>
       </pc:sldChg>
-      <pc:sldChg chg="addSp delSp modSp new mod ord modClrScheme chgLayout">
-        <pc:chgData name="Lines, Todd" userId="afaf7c3a-e8aa-4568-882a-02ad8f9e19b0" providerId="ADAL" clId="{002822DB-EE53-4F2A-8F03-1C9D4C4542CA}" dt="2025-07-03T22:36:38.967" v="44"/>
+      <pc:sldChg chg="addSp delSp modSp mod">
+        <pc:chgData name="Lines, Todd" userId="afaf7c3a-e8aa-4568-882a-02ad8f9e19b0" providerId="ADAL" clId="{5FF5AC1B-ABA9-43D7-A1E3-2D92732CD6E2}" dt="2026-03-27T17:11:16.865" v="4" actId="21"/>
         <pc:sldMkLst>
           <pc:docMk/>
           <pc:sldMk cId="3225564050" sldId="467"/>
         </pc:sldMkLst>
-        <pc:picChg chg="add mod">
-          <ac:chgData name="Lines, Todd" userId="afaf7c3a-e8aa-4568-882a-02ad8f9e19b0" providerId="ADAL" clId="{002822DB-EE53-4F2A-8F03-1C9D4C4542CA}" dt="2025-07-03T22:36:05.687" v="42" actId="1076"/>
+        <pc:picChg chg="del mod">
+          <ac:chgData name="Lines, Todd" userId="afaf7c3a-e8aa-4568-882a-02ad8f9e19b0" providerId="ADAL" clId="{5FF5AC1B-ABA9-43D7-A1E3-2D92732CD6E2}" dt="2026-03-27T17:11:16.865" v="4" actId="21"/>
           <ac:picMkLst>
             <pc:docMk/>
             <pc:sldMk cId="3225564050" sldId="467"/>
-            <ac:picMk id="5" creationId="{B6CBEDA1-2E2F-1F13-D234-0B692E47CB05}"/>
-          </ac:picMkLst>
-        </pc:picChg>
-      </pc:sldChg>
-      <pc:sldChg chg="addSp delSp modSp new mod">
-        <pc:chgData name="Lines, Todd" userId="afaf7c3a-e8aa-4568-882a-02ad8f9e19b0" providerId="ADAL" clId="{002822DB-EE53-4F2A-8F03-1C9D4C4542CA}" dt="2025-07-08T19:19:35.696" v="588" actId="21"/>
-        <pc:sldMkLst>
-          <pc:docMk/>
-          <pc:sldMk cId="3310950541" sldId="468"/>
-        </pc:sldMkLst>
-        <pc:picChg chg="add mod">
-          <ac:chgData name="Lines, Todd" userId="afaf7c3a-e8aa-4568-882a-02ad8f9e19b0" providerId="ADAL" clId="{002822DB-EE53-4F2A-8F03-1C9D4C4542CA}" dt="2025-07-08T19:19:20.174" v="585" actId="1076"/>
-          <ac:picMkLst>
-            <pc:docMk/>
-            <pc:sldMk cId="3310950541" sldId="468"/>
-            <ac:picMk id="5" creationId="{F8649D0B-6325-EE19-60F5-1B96276F79BA}"/>
+            <ac:picMk id="6" creationId="{9F4CF480-0FD1-2957-1EBB-C457545266AE}"/>
           </ac:picMkLst>
         </pc:picChg>
         <pc:cxnChg chg="add mod">
-          <ac:chgData name="Lines, Todd" userId="afaf7c3a-e8aa-4568-882a-02ad8f9e19b0" providerId="ADAL" clId="{002822DB-EE53-4F2A-8F03-1C9D4C4542CA}" dt="2025-07-08T19:19:08.677" v="584" actId="1035"/>
+          <ac:chgData name="Lines, Todd" userId="afaf7c3a-e8aa-4568-882a-02ad8f9e19b0" providerId="ADAL" clId="{5FF5AC1B-ABA9-43D7-A1E3-2D92732CD6E2}" dt="2026-03-27T17:10:56.316" v="1" actId="1076"/>
           <ac:cxnSpMkLst>
             <pc:docMk/>
-            <pc:sldMk cId="3310950541" sldId="468"/>
-            <ac:cxnSpMk id="2" creationId="{E90AD6E6-3547-0EDD-4101-F1F57F1FF309}"/>
-          </ac:cxnSpMkLst>
-        </pc:cxnChg>
-      </pc:sldChg>
-      <pc:sldChg chg="addSp delSp modSp new mod">
-        <pc:chgData name="Lines, Todd" userId="afaf7c3a-e8aa-4568-882a-02ad8f9e19b0" providerId="ADAL" clId="{002822DB-EE53-4F2A-8F03-1C9D4C4542CA}" dt="2025-07-18T17:50:38.547" v="636" actId="21"/>
-        <pc:sldMkLst>
-          <pc:docMk/>
-          <pc:sldMk cId="3744036023" sldId="469"/>
-        </pc:sldMkLst>
-        <pc:picChg chg="add del mod">
-          <ac:chgData name="Lines, Todd" userId="afaf7c3a-e8aa-4568-882a-02ad8f9e19b0" providerId="ADAL" clId="{002822DB-EE53-4F2A-8F03-1C9D4C4542CA}" dt="2025-07-18T17:49:58.698" v="628" actId="478"/>
-          <ac:picMkLst>
-            <pc:docMk/>
-            <pc:sldMk cId="3744036023" sldId="469"/>
-            <ac:picMk id="5" creationId="{E8B8C2B6-2DC3-3AF5-4331-B1B2288CFE46}"/>
-          </ac:picMkLst>
-        </pc:picChg>
-        <pc:picChg chg="del mod">
-          <ac:chgData name="Lines, Todd" userId="afaf7c3a-e8aa-4568-882a-02ad8f9e19b0" providerId="ADAL" clId="{002822DB-EE53-4F2A-8F03-1C9D4C4542CA}" dt="2025-07-18T17:48:05.763" v="611" actId="21"/>
-          <ac:picMkLst>
-            <pc:docMk/>
-            <pc:sldMk cId="3744036023" sldId="469"/>
-            <ac:picMk id="8" creationId="{73F4AFD3-BF4C-7479-8F72-7DECCD07E1A2}"/>
-          </ac:picMkLst>
-        </pc:picChg>
-        <pc:picChg chg="add del mod">
-          <ac:chgData name="Lines, Todd" userId="afaf7c3a-e8aa-4568-882a-02ad8f9e19b0" providerId="ADAL" clId="{002822DB-EE53-4F2A-8F03-1C9D4C4542CA}" dt="2025-07-18T17:49:24.184" v="622" actId="478"/>
-          <ac:picMkLst>
-            <pc:docMk/>
-            <pc:sldMk cId="3744036023" sldId="469"/>
-            <ac:picMk id="10" creationId="{DE93C005-7A88-8067-562F-8EC4C9DCB96F}"/>
-          </ac:picMkLst>
-        </pc:picChg>
-        <pc:picChg chg="add mod">
-          <ac:chgData name="Lines, Todd" userId="afaf7c3a-e8aa-4568-882a-02ad8f9e19b0" providerId="ADAL" clId="{002822DB-EE53-4F2A-8F03-1C9D4C4542CA}" dt="2025-07-18T17:49:29.618" v="623"/>
-          <ac:picMkLst>
-            <pc:docMk/>
-            <pc:sldMk cId="3744036023" sldId="469"/>
-            <ac:picMk id="14" creationId="{8E9D90FE-9859-9131-6FEF-9302CAFC1003}"/>
-          </ac:picMkLst>
-        </pc:picChg>
-        <pc:picChg chg="del mod">
-          <ac:chgData name="Lines, Todd" userId="afaf7c3a-e8aa-4568-882a-02ad8f9e19b0" providerId="ADAL" clId="{002822DB-EE53-4F2A-8F03-1C9D4C4542CA}" dt="2025-07-18T17:49:48.970" v="626" actId="478"/>
-          <ac:picMkLst>
-            <pc:docMk/>
-            <pc:sldMk cId="3744036023" sldId="469"/>
-            <ac:picMk id="18" creationId="{9302FB6F-5AB7-2EA5-0F30-7DE535A569F0}"/>
-          </ac:picMkLst>
-        </pc:picChg>
-        <pc:picChg chg="del mod">
-          <ac:chgData name="Lines, Todd" userId="afaf7c3a-e8aa-4568-882a-02ad8f9e19b0" providerId="ADAL" clId="{002822DB-EE53-4F2A-8F03-1C9D4C4542CA}" dt="2025-07-18T17:50:38.547" v="636" actId="21"/>
-          <ac:picMkLst>
-            <pc:docMk/>
-            <pc:sldMk cId="3744036023" sldId="469"/>
-            <ac:picMk id="19" creationId="{FA5AEBA2-5702-B30C-513A-2CE84FE664C6}"/>
-          </ac:picMkLst>
-        </pc:picChg>
-        <pc:cxnChg chg="add del mod ord">
-          <ac:chgData name="Lines, Todd" userId="afaf7c3a-e8aa-4568-882a-02ad8f9e19b0" providerId="ADAL" clId="{002822DB-EE53-4F2A-8F03-1C9D4C4542CA}" dt="2025-07-18T17:50:05.801" v="629" actId="478"/>
-          <ac:cxnSpMkLst>
-            <pc:docMk/>
-            <pc:sldMk cId="3744036023" sldId="469"/>
-            <ac:cxnSpMk id="2" creationId="{2B34615C-03A8-8887-A787-5DFCE08ABDB9}"/>
+            <pc:sldMk cId="3225564050" sldId="467"/>
+            <ac:cxnSpMk id="2" creationId="{534048EF-BCD1-8FD4-F157-9933F29C4079}"/>
           </ac:cxnSpMkLst>
         </pc:cxnChg>
         <pc:cxnChg chg="add mod">
-          <ac:chgData name="Lines, Todd" userId="afaf7c3a-e8aa-4568-882a-02ad8f9e19b0" providerId="ADAL" clId="{002822DB-EE53-4F2A-8F03-1C9D4C4542CA}" dt="2025-07-18T17:47:53.609" v="609" actId="1036"/>
+          <ac:chgData name="Lines, Todd" userId="afaf7c3a-e8aa-4568-882a-02ad8f9e19b0" providerId="ADAL" clId="{5FF5AC1B-ABA9-43D7-A1E3-2D92732CD6E2}" dt="2026-03-27T17:11:01.240" v="2" actId="14100"/>
           <ac:cxnSpMkLst>
             <pc:docMk/>
-            <pc:sldMk cId="3744036023" sldId="469"/>
-            <ac:cxnSpMk id="4" creationId="{ACFF82DA-979A-3AFB-D691-10055ACDC352}"/>
+            <pc:sldMk cId="3225564050" sldId="467"/>
+            <ac:cxnSpMk id="3" creationId="{0216E21E-2912-1332-6E5F-46E529E61FA8}"/>
           </ac:cxnSpMkLst>
         </pc:cxnChg>
-        <pc:cxnChg chg="add mod">
-          <ac:chgData name="Lines, Todd" userId="afaf7c3a-e8aa-4568-882a-02ad8f9e19b0" providerId="ADAL" clId="{002822DB-EE53-4F2A-8F03-1C9D4C4542CA}" dt="2025-07-18T17:48:58.895" v="618" actId="1582"/>
-          <ac:cxnSpMkLst>
-            <pc:docMk/>
-            <pc:sldMk cId="3744036023" sldId="469"/>
-            <ac:cxnSpMk id="7" creationId="{6FBF6BC9-6961-A8F3-984A-481B042B1B81}"/>
-          </ac:cxnSpMkLst>
-        </pc:cxnChg>
-        <pc:cxnChg chg="add del mod">
-          <ac:chgData name="Lines, Todd" userId="afaf7c3a-e8aa-4568-882a-02ad8f9e19b0" providerId="ADAL" clId="{002822DB-EE53-4F2A-8F03-1C9D4C4542CA}" dt="2025-07-18T17:49:24.184" v="622" actId="478"/>
-          <ac:cxnSpMkLst>
-            <pc:docMk/>
-            <pc:sldMk cId="3744036023" sldId="469"/>
-            <ac:cxnSpMk id="11" creationId="{E88E7EB0-37A8-DD84-29E2-8D97C52D519E}"/>
-          </ac:cxnSpMkLst>
-        </pc:cxnChg>
-        <pc:cxnChg chg="add del mod">
-          <ac:chgData name="Lines, Todd" userId="afaf7c3a-e8aa-4568-882a-02ad8f9e19b0" providerId="ADAL" clId="{002822DB-EE53-4F2A-8F03-1C9D4C4542CA}" dt="2025-07-18T17:49:24.184" v="622" actId="478"/>
-          <ac:cxnSpMkLst>
-            <pc:docMk/>
-            <pc:sldMk cId="3744036023" sldId="469"/>
-            <ac:cxnSpMk id="12" creationId="{83BD2C6C-B085-903F-6CFF-3FCB9ED83600}"/>
-          </ac:cxnSpMkLst>
-        </pc:cxnChg>
-        <pc:cxnChg chg="add del mod">
-          <ac:chgData name="Lines, Todd" userId="afaf7c3a-e8aa-4568-882a-02ad8f9e19b0" providerId="ADAL" clId="{002822DB-EE53-4F2A-8F03-1C9D4C4542CA}" dt="2025-07-18T17:49:24.184" v="622" actId="478"/>
-          <ac:cxnSpMkLst>
-            <pc:docMk/>
-            <pc:sldMk cId="3744036023" sldId="469"/>
-            <ac:cxnSpMk id="13" creationId="{78EA0778-61EE-D51F-3AAD-68A7AAB86584}"/>
-          </ac:cxnSpMkLst>
-        </pc:cxnChg>
-        <pc:cxnChg chg="add mod">
-          <ac:chgData name="Lines, Todd" userId="afaf7c3a-e8aa-4568-882a-02ad8f9e19b0" providerId="ADAL" clId="{002822DB-EE53-4F2A-8F03-1C9D4C4542CA}" dt="2025-07-18T17:49:29.618" v="623"/>
-          <ac:cxnSpMkLst>
-            <pc:docMk/>
-            <pc:sldMk cId="3744036023" sldId="469"/>
-            <ac:cxnSpMk id="15" creationId="{7CC3A4AD-E3C7-1F8F-8E47-BEF3A11FA1EB}"/>
-          </ac:cxnSpMkLst>
-        </pc:cxnChg>
-        <pc:cxnChg chg="add mod">
-          <ac:chgData name="Lines, Todd" userId="afaf7c3a-e8aa-4568-882a-02ad8f9e19b0" providerId="ADAL" clId="{002822DB-EE53-4F2A-8F03-1C9D4C4542CA}" dt="2025-07-18T17:49:29.618" v="623"/>
-          <ac:cxnSpMkLst>
-            <pc:docMk/>
-            <pc:sldMk cId="3744036023" sldId="469"/>
-            <ac:cxnSpMk id="16" creationId="{9CB70B8F-6FCD-7EBD-F47D-134E1E54C66E}"/>
-          </ac:cxnSpMkLst>
-        </pc:cxnChg>
-        <pc:cxnChg chg="add mod">
-          <ac:chgData name="Lines, Todd" userId="afaf7c3a-e8aa-4568-882a-02ad8f9e19b0" providerId="ADAL" clId="{002822DB-EE53-4F2A-8F03-1C9D4C4542CA}" dt="2025-07-18T17:50:23.922" v="633" actId="692"/>
-          <ac:cxnSpMkLst>
-            <pc:docMk/>
-            <pc:sldMk cId="3744036023" sldId="469"/>
-            <ac:cxnSpMk id="17" creationId="{51F59622-C043-2EC3-B061-4FFA439E6FEB}"/>
-          </ac:cxnSpMkLst>
-        </pc:cxnChg>
-      </pc:sldChg>
-      <pc:sldChg chg="addSp delSp modSp new mod">
-        <pc:chgData name="Lines, Todd" userId="afaf7c3a-e8aa-4568-882a-02ad8f9e19b0" providerId="ADAL" clId="{002822DB-EE53-4F2A-8F03-1C9D4C4542CA}" dt="2025-07-03T22:37:32.638" v="61" actId="1076"/>
-        <pc:sldMkLst>
-          <pc:docMk/>
-          <pc:sldMk cId="3767091076" sldId="470"/>
-        </pc:sldMkLst>
-        <pc:picChg chg="add mod">
-          <ac:chgData name="Lines, Todd" userId="afaf7c3a-e8aa-4568-882a-02ad8f9e19b0" providerId="ADAL" clId="{002822DB-EE53-4F2A-8F03-1C9D4C4542CA}" dt="2025-07-03T22:37:32.638" v="61" actId="1076"/>
-          <ac:picMkLst>
-            <pc:docMk/>
-            <pc:sldMk cId="3767091076" sldId="470"/>
-            <ac:picMk id="5" creationId="{EC5A76F3-495D-894A-F2FD-44A0958FCBE0}"/>
-          </ac:picMkLst>
-        </pc:picChg>
-      </pc:sldChg>
-      <pc:sldChg chg="add">
-        <pc:chgData name="Lines, Todd" userId="afaf7c3a-e8aa-4568-882a-02ad8f9e19b0" providerId="ADAL" clId="{002822DB-EE53-4F2A-8F03-1C9D4C4542CA}" dt="2025-07-03T22:41:13.043" v="62"/>
-        <pc:sldMkLst>
-          <pc:docMk/>
-          <pc:sldMk cId="0" sldId="471"/>
-        </pc:sldMkLst>
-      </pc:sldChg>
-      <pc:sldChg chg="addSp delSp modSp new mod">
-        <pc:chgData name="Lines, Todd" userId="afaf7c3a-e8aa-4568-882a-02ad8f9e19b0" providerId="ADAL" clId="{002822DB-EE53-4F2A-8F03-1C9D4C4542CA}" dt="2025-07-03T22:41:32.324" v="67" actId="14100"/>
-        <pc:sldMkLst>
-          <pc:docMk/>
-          <pc:sldMk cId="4261913918" sldId="472"/>
-        </pc:sldMkLst>
-        <pc:picChg chg="add mod">
-          <ac:chgData name="Lines, Todd" userId="afaf7c3a-e8aa-4568-882a-02ad8f9e19b0" providerId="ADAL" clId="{002822DB-EE53-4F2A-8F03-1C9D4C4542CA}" dt="2025-07-03T22:41:32.324" v="67" actId="14100"/>
-          <ac:picMkLst>
-            <pc:docMk/>
-            <pc:sldMk cId="4261913918" sldId="472"/>
-            <ac:picMk id="5" creationId="{577E6E97-3A9B-1B9A-33BE-F5A5B5A2DD75}"/>
-          </ac:picMkLst>
-        </pc:picChg>
-      </pc:sldChg>
-      <pc:sldChg chg="add">
-        <pc:chgData name="Lines, Todd" userId="afaf7c3a-e8aa-4568-882a-02ad8f9e19b0" providerId="ADAL" clId="{002822DB-EE53-4F2A-8F03-1C9D4C4542CA}" dt="2025-07-03T22:41:44.751" v="68"/>
-        <pc:sldMkLst>
-          <pc:docMk/>
-          <pc:sldMk cId="0" sldId="473"/>
-        </pc:sldMkLst>
-      </pc:sldChg>
-      <pc:sldChg chg="addSp modSp add mod chgLayout">
-        <pc:chgData name="Lines, Todd" userId="afaf7c3a-e8aa-4568-882a-02ad8f9e19b0" providerId="ADAL" clId="{002822DB-EE53-4F2A-8F03-1C9D4C4542CA}" dt="2025-07-08T18:41:31.210" v="450" actId="313"/>
-        <pc:sldMkLst>
-          <pc:docMk/>
-          <pc:sldMk cId="3901738404" sldId="474"/>
-        </pc:sldMkLst>
-        <pc:spChg chg="add mod ord">
-          <ac:chgData name="Lines, Todd" userId="afaf7c3a-e8aa-4568-882a-02ad8f9e19b0" providerId="ADAL" clId="{002822DB-EE53-4F2A-8F03-1C9D4C4542CA}" dt="2025-07-08T15:59:06.999" v="81" actId="20577"/>
-          <ac:spMkLst>
-            <pc:docMk/>
-            <pc:sldMk cId="3901738404" sldId="474"/>
-            <ac:spMk id="2" creationId="{20AA1F2A-A60F-5CC6-29F9-7C434BDC104D}"/>
-          </ac:spMkLst>
-        </pc:spChg>
-        <pc:spChg chg="add mod ord">
-          <ac:chgData name="Lines, Todd" userId="afaf7c3a-e8aa-4568-882a-02ad8f9e19b0" providerId="ADAL" clId="{002822DB-EE53-4F2A-8F03-1C9D4C4542CA}" dt="2025-07-08T18:41:31.210" v="450" actId="313"/>
-          <ac:spMkLst>
-            <pc:docMk/>
-            <pc:sldMk cId="3901738404" sldId="474"/>
-            <ac:spMk id="3" creationId="{F3E64571-AD3A-7F73-C2F0-EC24A6C543A7}"/>
-          </ac:spMkLst>
-        </pc:spChg>
-        <pc:picChg chg="mod">
-          <ac:chgData name="Lines, Todd" userId="afaf7c3a-e8aa-4568-882a-02ad8f9e19b0" providerId="ADAL" clId="{002822DB-EE53-4F2A-8F03-1C9D4C4542CA}" dt="2025-07-08T16:00:04.672" v="230" actId="1076"/>
-          <ac:picMkLst>
-            <pc:docMk/>
-            <pc:sldMk cId="3901738404" sldId="474"/>
-            <ac:picMk id="5" creationId="{84CD3C38-E32A-DCD7-C449-240C2C4A2735}"/>
-          </ac:picMkLst>
-        </pc:picChg>
-        <pc:cxnChg chg="add mod">
-          <ac:chgData name="Lines, Todd" userId="afaf7c3a-e8aa-4568-882a-02ad8f9e19b0" providerId="ADAL" clId="{002822DB-EE53-4F2A-8F03-1C9D4C4542CA}" dt="2025-07-08T16:00:15.217" v="232" actId="208"/>
-          <ac:cxnSpMkLst>
-            <pc:docMk/>
-            <pc:sldMk cId="3901738404" sldId="474"/>
-            <ac:cxnSpMk id="6" creationId="{FDCE3B62-BC43-1B02-EA7C-DEE19FE26AF3}"/>
-          </ac:cxnSpMkLst>
-        </pc:cxnChg>
-      </pc:sldChg>
-      <pc:sldChg chg="addSp delSp modSp add mod">
-        <pc:chgData name="Lines, Todd" userId="afaf7c3a-e8aa-4568-882a-02ad8f9e19b0" providerId="ADAL" clId="{002822DB-EE53-4F2A-8F03-1C9D4C4542CA}" dt="2025-07-08T19:18:35.621" v="576" actId="1035"/>
-        <pc:sldMkLst>
-          <pc:docMk/>
-          <pc:sldMk cId="1455729989" sldId="475"/>
-        </pc:sldMkLst>
-        <pc:picChg chg="add mod ord">
-          <ac:chgData name="Lines, Todd" userId="afaf7c3a-e8aa-4568-882a-02ad8f9e19b0" providerId="ADAL" clId="{002822DB-EE53-4F2A-8F03-1C9D4C4542CA}" dt="2025-07-08T16:00:50.575" v="238" actId="1076"/>
-          <ac:picMkLst>
-            <pc:docMk/>
-            <pc:sldMk cId="1455729989" sldId="475"/>
-            <ac:picMk id="4" creationId="{6CCE7247-AF99-178F-8AA3-BACE43C1D3FE}"/>
-          </ac:picMkLst>
-        </pc:picChg>
-        <pc:cxnChg chg="mod">
-          <ac:chgData name="Lines, Todd" userId="afaf7c3a-e8aa-4568-882a-02ad8f9e19b0" providerId="ADAL" clId="{002822DB-EE53-4F2A-8F03-1C9D4C4542CA}" dt="2025-07-08T19:18:35.621" v="576" actId="1035"/>
-          <ac:cxnSpMkLst>
-            <pc:docMk/>
-            <pc:sldMk cId="1455729989" sldId="475"/>
-            <ac:cxnSpMk id="6" creationId="{F47F3268-0BAF-BFCA-29DE-39D5DA409961}"/>
-          </ac:cxnSpMkLst>
-        </pc:cxnChg>
-      </pc:sldChg>
-      <pc:sldChg chg="modSp add mod">
-        <pc:chgData name="Lines, Todd" userId="afaf7c3a-e8aa-4568-882a-02ad8f9e19b0" providerId="ADAL" clId="{002822DB-EE53-4F2A-8F03-1C9D4C4542CA}" dt="2025-07-08T16:01:58.751" v="381" actId="27636"/>
-        <pc:sldMkLst>
-          <pc:docMk/>
-          <pc:sldMk cId="3465337476" sldId="476"/>
-        </pc:sldMkLst>
-        <pc:spChg chg="mod">
-          <ac:chgData name="Lines, Todd" userId="afaf7c3a-e8aa-4568-882a-02ad8f9e19b0" providerId="ADAL" clId="{002822DB-EE53-4F2A-8F03-1C9D4C4542CA}" dt="2025-07-08T16:01:58.751" v="381" actId="27636"/>
-          <ac:spMkLst>
-            <pc:docMk/>
-            <pc:sldMk cId="3465337476" sldId="476"/>
-            <ac:spMk id="3" creationId="{87F41BFB-98F0-D02C-5367-860D80FB692B}"/>
-          </ac:spMkLst>
-        </pc:spChg>
-      </pc:sldChg>
-      <pc:sldChg chg="addSp delSp modSp add mod">
-        <pc:chgData name="Lines, Todd" userId="afaf7c3a-e8aa-4568-882a-02ad8f9e19b0" providerId="ADAL" clId="{002822DB-EE53-4F2A-8F03-1C9D4C4542CA}" dt="2025-07-08T19:35:40.494" v="594" actId="1035"/>
-        <pc:sldMkLst>
-          <pc:docMk/>
-          <pc:sldMk cId="148843540" sldId="477"/>
-        </pc:sldMkLst>
-        <pc:picChg chg="add mod">
-          <ac:chgData name="Lines, Todd" userId="afaf7c3a-e8aa-4568-882a-02ad8f9e19b0" providerId="ADAL" clId="{002822DB-EE53-4F2A-8F03-1C9D4C4542CA}" dt="2025-07-08T16:02:29.753" v="384"/>
-          <ac:picMkLst>
-            <pc:docMk/>
-            <pc:sldMk cId="148843540" sldId="477"/>
-            <ac:picMk id="4" creationId="{44953FE4-1737-7FA7-D99D-6BC35F8D05F6}"/>
-          </ac:picMkLst>
-        </pc:picChg>
-        <pc:cxnChg chg="add mod">
-          <ac:chgData name="Lines, Todd" userId="afaf7c3a-e8aa-4568-882a-02ad8f9e19b0" providerId="ADAL" clId="{002822DB-EE53-4F2A-8F03-1C9D4C4542CA}" dt="2025-07-08T19:35:40.494" v="594" actId="1035"/>
-          <ac:cxnSpMkLst>
-            <pc:docMk/>
-            <pc:sldMk cId="148843540" sldId="477"/>
-            <ac:cxnSpMk id="7" creationId="{B6141E50-A300-85A4-7692-1C3F2329E3A7}"/>
-          </ac:cxnSpMkLst>
-        </pc:cxnChg>
-      </pc:sldChg>
-      <pc:sldChg chg="addSp delSp modSp add mod">
-        <pc:chgData name="Lines, Todd" userId="afaf7c3a-e8aa-4568-882a-02ad8f9e19b0" providerId="ADAL" clId="{002822DB-EE53-4F2A-8F03-1C9D4C4542CA}" dt="2025-07-18T17:51:46.494" v="641" actId="21"/>
-        <pc:sldMkLst>
-          <pc:docMk/>
-          <pc:sldMk cId="6673116" sldId="478"/>
-        </pc:sldMkLst>
-        <pc:spChg chg="mod">
-          <ac:chgData name="Lines, Todd" userId="afaf7c3a-e8aa-4568-882a-02ad8f9e19b0" providerId="ADAL" clId="{002822DB-EE53-4F2A-8F03-1C9D4C4542CA}" dt="2025-07-08T18:43:06.493" v="455" actId="313"/>
-          <ac:spMkLst>
-            <pc:docMk/>
-            <pc:sldMk cId="6673116" sldId="478"/>
-            <ac:spMk id="3" creationId="{3B133359-F837-BC48-4156-8016D7E11C67}"/>
-          </ac:spMkLst>
-        </pc:spChg>
-        <pc:picChg chg="add mod">
-          <ac:chgData name="Lines, Todd" userId="afaf7c3a-e8aa-4568-882a-02ad8f9e19b0" providerId="ADAL" clId="{002822DB-EE53-4F2A-8F03-1C9D4C4542CA}" dt="2025-07-08T18:40:18.527" v="391" actId="1076"/>
-          <ac:picMkLst>
-            <pc:docMk/>
-            <pc:sldMk cId="6673116" sldId="478"/>
-            <ac:picMk id="4" creationId="{5E193EE2-C47E-7850-F4DD-C8F3EEC111DE}"/>
-          </ac:picMkLst>
-        </pc:picChg>
-        <pc:picChg chg="del">
-          <ac:chgData name="Lines, Todd" userId="afaf7c3a-e8aa-4568-882a-02ad8f9e19b0" providerId="ADAL" clId="{002822DB-EE53-4F2A-8F03-1C9D4C4542CA}" dt="2025-07-18T17:51:24.042" v="637" actId="478"/>
-          <ac:picMkLst>
-            <pc:docMk/>
-            <pc:sldMk cId="6673116" sldId="478"/>
-            <ac:picMk id="5" creationId="{170865E7-A6BD-1A32-5507-3A243EA9EF79}"/>
-          </ac:picMkLst>
-        </pc:picChg>
-        <pc:picChg chg="del mod">
-          <ac:chgData name="Lines, Todd" userId="afaf7c3a-e8aa-4568-882a-02ad8f9e19b0" providerId="ADAL" clId="{002822DB-EE53-4F2A-8F03-1C9D4C4542CA}" dt="2025-07-18T17:51:46.494" v="641" actId="21"/>
-          <ac:picMkLst>
-            <pc:docMk/>
-            <pc:sldMk cId="6673116" sldId="478"/>
-            <ac:picMk id="7" creationId="{CF33ACDC-A152-AF34-E86F-0F0BF18DF036}"/>
-          </ac:picMkLst>
-        </pc:picChg>
-        <pc:cxnChg chg="mod ord">
-          <ac:chgData name="Lines, Todd" userId="afaf7c3a-e8aa-4568-882a-02ad8f9e19b0" providerId="ADAL" clId="{002822DB-EE53-4F2A-8F03-1C9D4C4542CA}" dt="2025-07-18T17:51:35.140" v="639" actId="692"/>
-          <ac:cxnSpMkLst>
-            <pc:docMk/>
-            <pc:sldMk cId="6673116" sldId="478"/>
-            <ac:cxnSpMk id="6" creationId="{2081A4D1-E4E2-F7A7-A308-0E91C696AE34}"/>
-          </ac:cxnSpMkLst>
-        </pc:cxnChg>
-      </pc:sldChg>
-      <pc:sldChg chg="addSp delSp modSp add mod">
-        <pc:chgData name="Lines, Todd" userId="afaf7c3a-e8aa-4568-882a-02ad8f9e19b0" providerId="ADAL" clId="{002822DB-EE53-4F2A-8F03-1C9D4C4542CA}" dt="2025-07-08T18:42:13.563" v="454" actId="1076"/>
-        <pc:sldMkLst>
-          <pc:docMk/>
-          <pc:sldMk cId="1395796797" sldId="479"/>
-        </pc:sldMkLst>
-        <pc:picChg chg="add mod">
-          <ac:chgData name="Lines, Todd" userId="afaf7c3a-e8aa-4568-882a-02ad8f9e19b0" providerId="ADAL" clId="{002822DB-EE53-4F2A-8F03-1C9D4C4542CA}" dt="2025-07-08T18:42:13.563" v="454" actId="1076"/>
-          <ac:picMkLst>
-            <pc:docMk/>
-            <pc:sldMk cId="1395796797" sldId="479"/>
-            <ac:picMk id="4" creationId="{9962E8B0-9050-503B-9091-1EDA47E2D28F}"/>
-          </ac:picMkLst>
-        </pc:picChg>
-        <pc:cxnChg chg="add mod">
-          <ac:chgData name="Lines, Todd" userId="afaf7c3a-e8aa-4568-882a-02ad8f9e19b0" providerId="ADAL" clId="{002822DB-EE53-4F2A-8F03-1C9D4C4542CA}" dt="2025-07-08T18:42:13.563" v="454" actId="1076"/>
-          <ac:cxnSpMkLst>
-            <pc:docMk/>
-            <pc:sldMk cId="1395796797" sldId="479"/>
-            <ac:cxnSpMk id="7" creationId="{12CEA0B4-9B95-6447-98D6-0F38E0037934}"/>
-          </ac:cxnSpMkLst>
-        </pc:cxnChg>
-      </pc:sldChg>
-      <pc:sldChg chg="addSp delSp modSp new mod ord">
-        <pc:chgData name="Lines, Todd" userId="afaf7c3a-e8aa-4568-882a-02ad8f9e19b0" providerId="ADAL" clId="{002822DB-EE53-4F2A-8F03-1C9D4C4542CA}" dt="2025-07-08T19:03:21.752" v="559"/>
-        <pc:sldMkLst>
-          <pc:docMk/>
-          <pc:sldMk cId="1397824895" sldId="480"/>
-        </pc:sldMkLst>
-        <pc:picChg chg="add">
-          <ac:chgData name="Lines, Todd" userId="afaf7c3a-e8aa-4568-882a-02ad8f9e19b0" providerId="ADAL" clId="{002822DB-EE53-4F2A-8F03-1C9D4C4542CA}" dt="2025-07-08T18:50:05.430" v="460" actId="22"/>
-          <ac:picMkLst>
-            <pc:docMk/>
-            <pc:sldMk cId="1397824895" sldId="480"/>
-            <ac:picMk id="7" creationId="{4CBFB42F-3F0E-C08B-4644-798D61BFA10D}"/>
-          </ac:picMkLst>
-        </pc:picChg>
-      </pc:sldChg>
-      <pc:sldChg chg="add del">
-        <pc:chgData name="Lines, Todd" userId="afaf7c3a-e8aa-4568-882a-02ad8f9e19b0" providerId="ADAL" clId="{002822DB-EE53-4F2A-8F03-1C9D4C4542CA}" dt="2025-07-08T18:53:45.972" v="463"/>
-        <pc:sldMkLst>
-          <pc:docMk/>
-          <pc:sldMk cId="0" sldId="481"/>
-        </pc:sldMkLst>
-      </pc:sldChg>
-      <pc:sldChg chg="modSp add mod ord">
-        <pc:chgData name="Lines, Todd" userId="afaf7c3a-e8aa-4568-882a-02ad8f9e19b0" providerId="ADAL" clId="{002822DB-EE53-4F2A-8F03-1C9D4C4542CA}" dt="2025-07-08T19:03:11.468" v="557" actId="20577"/>
-        <pc:sldMkLst>
-          <pc:docMk/>
-          <pc:sldMk cId="0" sldId="482"/>
-        </pc:sldMkLst>
-        <pc:spChg chg="mod">
-          <ac:chgData name="Lines, Todd" userId="afaf7c3a-e8aa-4568-882a-02ad8f9e19b0" providerId="ADAL" clId="{002822DB-EE53-4F2A-8F03-1C9D4C4542CA}" dt="2025-07-08T19:03:11.468" v="557" actId="20577"/>
-          <ac:spMkLst>
-            <pc:docMk/>
-            <pc:sldMk cId="0" sldId="482"/>
-            <ac:spMk id="17410" creationId="{E6D39776-0E6E-C21B-F667-CEE4AFDB8BC7}"/>
-          </ac:spMkLst>
-        </pc:spChg>
-        <pc:spChg chg="mod">
-          <ac:chgData name="Lines, Todd" userId="afaf7c3a-e8aa-4568-882a-02ad8f9e19b0" providerId="ADAL" clId="{002822DB-EE53-4F2A-8F03-1C9D4C4542CA}" dt="2025-07-08T19:02:56.669" v="555" actId="20577"/>
-          <ac:spMkLst>
-            <pc:docMk/>
-            <pc:sldMk cId="0" sldId="482"/>
-            <ac:spMk id="17411" creationId="{9DDAEF39-43C0-F461-FEF1-3FC64669D58D}"/>
-          </ac:spMkLst>
-        </pc:spChg>
-      </pc:sldChg>
-      <pc:sldChg chg="add ord">
-        <pc:chgData name="Lines, Todd" userId="afaf7c3a-e8aa-4568-882a-02ad8f9e19b0" providerId="ADAL" clId="{002822DB-EE53-4F2A-8F03-1C9D4C4542CA}" dt="2025-07-08T19:03:35.320" v="561"/>
-        <pc:sldMkLst>
-          <pc:docMk/>
-          <pc:sldMk cId="0" sldId="483"/>
-        </pc:sldMkLst>
-      </pc:sldChg>
-      <pc:sldChg chg="modSp add mod">
-        <pc:chgData name="Lines, Todd" userId="afaf7c3a-e8aa-4568-882a-02ad8f9e19b0" providerId="ADAL" clId="{002822DB-EE53-4F2A-8F03-1C9D4C4542CA}" dt="2025-07-08T18:56:23.087" v="486" actId="313"/>
-        <pc:sldMkLst>
-          <pc:docMk/>
-          <pc:sldMk cId="0" sldId="484"/>
-        </pc:sldMkLst>
-        <pc:spChg chg="mod">
-          <ac:chgData name="Lines, Todd" userId="afaf7c3a-e8aa-4568-882a-02ad8f9e19b0" providerId="ADAL" clId="{002822DB-EE53-4F2A-8F03-1C9D4C4542CA}" dt="2025-07-08T18:56:23.087" v="486" actId="313"/>
-          <ac:spMkLst>
-            <pc:docMk/>
-            <pc:sldMk cId="0" sldId="484"/>
-            <ac:spMk id="35843" creationId="{25E6F564-0ACC-BFA0-5D1C-098F0645008F}"/>
-          </ac:spMkLst>
-        </pc:spChg>
-      </pc:sldChg>
-      <pc:sldChg chg="add ord">
-        <pc:chgData name="Lines, Todd" userId="afaf7c3a-e8aa-4568-882a-02ad8f9e19b0" providerId="ADAL" clId="{002822DB-EE53-4F2A-8F03-1C9D4C4542CA}" dt="2025-07-08T19:02:08.281" v="488"/>
-        <pc:sldMkLst>
-          <pc:docMk/>
-          <pc:sldMk cId="0" sldId="485"/>
-        </pc:sldMkLst>
       </pc:sldChg>
     </pc:docChg>
   </pc:docChgLst>
@@ -857,7 +322,7 @@
           <a:p>
             <a:fld id="{87F53586-FF55-42A0-B419-AF2ACE7CF085}" type="datetimeFigureOut">
               <a:rPr lang="en-US" smtClean="0"/>
-              <a:t>7/18/2025</a:t>
+              <a:t>3/27/2026</a:t>
             </a:fld>
             <a:endParaRPr lang="en-US"/>
           </a:p>
@@ -1388,7 +853,7 @@
             <a:fld id="{3F384AAD-F2F7-440E-A41C-6B3FA172D4A3}" type="datetimeFigureOut">
               <a:rPr lang="en-US" smtClean="0"/>
               <a:pPr/>
-              <a:t>7/18/2025</a:t>
+              <a:t>3/27/2026</a:t>
             </a:fld>
             <a:endParaRPr lang="en-US"/>
           </a:p>
@@ -1553,7 +1018,7 @@
             <a:fld id="{3F384AAD-F2F7-440E-A41C-6B3FA172D4A3}" type="datetimeFigureOut">
               <a:rPr lang="en-US" smtClean="0"/>
               <a:pPr/>
-              <a:t>7/18/2025</a:t>
+              <a:t>3/27/2026</a:t>
             </a:fld>
             <a:endParaRPr lang="en-US"/>
           </a:p>
@@ -1728,7 +1193,7 @@
             <a:fld id="{3F384AAD-F2F7-440E-A41C-6B3FA172D4A3}" type="datetimeFigureOut">
               <a:rPr lang="en-US" smtClean="0"/>
               <a:pPr/>
-              <a:t>7/18/2025</a:t>
+              <a:t>3/27/2026</a:t>
             </a:fld>
             <a:endParaRPr lang="en-US"/>
           </a:p>
@@ -1893,7 +1358,7 @@
             <a:fld id="{3F384AAD-F2F7-440E-A41C-6B3FA172D4A3}" type="datetimeFigureOut">
               <a:rPr lang="en-US" smtClean="0"/>
               <a:pPr/>
-              <a:t>7/18/2025</a:t>
+              <a:t>3/27/2026</a:t>
             </a:fld>
             <a:endParaRPr lang="en-US"/>
           </a:p>
@@ -2135,7 +1600,7 @@
             <a:fld id="{3F384AAD-F2F7-440E-A41C-6B3FA172D4A3}" type="datetimeFigureOut">
               <a:rPr lang="en-US" smtClean="0"/>
               <a:pPr/>
-              <a:t>7/18/2025</a:t>
+              <a:t>3/27/2026</a:t>
             </a:fld>
             <a:endParaRPr lang="en-US"/>
           </a:p>
@@ -2417,7 +1882,7 @@
             <a:fld id="{3F384AAD-F2F7-440E-A41C-6B3FA172D4A3}" type="datetimeFigureOut">
               <a:rPr lang="en-US" smtClean="0"/>
               <a:pPr/>
-              <a:t>7/18/2025</a:t>
+              <a:t>3/27/2026</a:t>
             </a:fld>
             <a:endParaRPr lang="en-US"/>
           </a:p>
@@ -2833,7 +2298,7 @@
             <a:fld id="{3F384AAD-F2F7-440E-A41C-6B3FA172D4A3}" type="datetimeFigureOut">
               <a:rPr lang="en-US" smtClean="0"/>
               <a:pPr/>
-              <a:t>7/18/2025</a:t>
+              <a:t>3/27/2026</a:t>
             </a:fld>
             <a:endParaRPr lang="en-US"/>
           </a:p>
@@ -2947,7 +2412,7 @@
             <a:fld id="{3F384AAD-F2F7-440E-A41C-6B3FA172D4A3}" type="datetimeFigureOut">
               <a:rPr lang="en-US" smtClean="0"/>
               <a:pPr/>
-              <a:t>7/18/2025</a:t>
+              <a:t>3/27/2026</a:t>
             </a:fld>
             <a:endParaRPr lang="en-US"/>
           </a:p>
@@ -3039,7 +2504,7 @@
             <a:fld id="{3F384AAD-F2F7-440E-A41C-6B3FA172D4A3}" type="datetimeFigureOut">
               <a:rPr lang="en-US" smtClean="0"/>
               <a:pPr/>
-              <a:t>7/18/2025</a:t>
+              <a:t>3/27/2026</a:t>
             </a:fld>
             <a:endParaRPr lang="en-US"/>
           </a:p>
@@ -3311,7 +2776,7 @@
             <a:fld id="{3F384AAD-F2F7-440E-A41C-6B3FA172D4A3}" type="datetimeFigureOut">
               <a:rPr lang="en-US" smtClean="0"/>
               <a:pPr/>
-              <a:t>7/18/2025</a:t>
+              <a:t>3/27/2026</a:t>
             </a:fld>
             <a:endParaRPr lang="en-US"/>
           </a:p>
@@ -3560,7 +3025,7 @@
             <a:fld id="{3F384AAD-F2F7-440E-A41C-6B3FA172D4A3}" type="datetimeFigureOut">
               <a:rPr lang="en-US" smtClean="0"/>
               <a:pPr/>
-              <a:t>7/18/2025</a:t>
+              <a:t>3/27/2026</a:t>
             </a:fld>
             <a:endParaRPr lang="en-US"/>
           </a:p>
@@ -3768,7 +3233,7 @@
             <a:fld id="{3F384AAD-F2F7-440E-A41C-6B3FA172D4A3}" type="datetimeFigureOut">
               <a:rPr lang="en-US" smtClean="0"/>
               <a:pPr/>
-              <a:t>7/18/2025</a:t>
+              <a:t>3/27/2026</a:t>
             </a:fld>
             <a:endParaRPr lang="en-US"/>
           </a:p>
@@ -4252,6 +3717,87 @@
           </a:prstGeom>
         </p:spPr>
       </p:pic>
+      <p:cxnSp>
+        <p:nvCxnSpPr>
+          <p:cNvPr id="2" name="Straight Arrow Connector 1">
+            <a:extLst>
+              <a:ext uri="{FF2B5EF4-FFF2-40B4-BE49-F238E27FC236}">
+                <a16:creationId xmlns:a16="http://schemas.microsoft.com/office/drawing/2014/main" id="{534048EF-BCD1-8FD4-F157-9933F29C4079}"/>
+              </a:ext>
+            </a:extLst>
+          </p:cNvPr>
+          <p:cNvCxnSpPr/>
+          <p:nvPr/>
+        </p:nvCxnSpPr>
+        <p:spPr>
+          <a:xfrm flipV="1">
+            <a:off x="5306568" y="2283714"/>
+            <a:ext cx="0" cy="285750"/>
+          </a:xfrm>
+          <a:prstGeom prst="straightConnector1">
+            <a:avLst/>
+          </a:prstGeom>
+          <a:ln w="28575">
+            <a:solidFill>
+              <a:schemeClr val="accent1"/>
+            </a:solidFill>
+            <a:tailEnd type="arrow"/>
+          </a:ln>
+        </p:spPr>
+        <p:style>
+          <a:lnRef idx="1">
+            <a:schemeClr val="accent1"/>
+          </a:lnRef>
+          <a:fillRef idx="0">
+            <a:schemeClr val="accent1"/>
+          </a:fillRef>
+          <a:effectRef idx="0">
+            <a:schemeClr val="accent1"/>
+          </a:effectRef>
+          <a:fontRef idx="minor">
+            <a:schemeClr val="tx1"/>
+          </a:fontRef>
+        </p:style>
+      </p:cxnSp>
+      <p:cxnSp>
+        <p:nvCxnSpPr>
+          <p:cNvPr id="3" name="Straight Connector 2">
+            <a:extLst>
+              <a:ext uri="{FF2B5EF4-FFF2-40B4-BE49-F238E27FC236}">
+                <a16:creationId xmlns:a16="http://schemas.microsoft.com/office/drawing/2014/main" id="{0216E21E-2912-1332-6E5F-46E529E61FA8}"/>
+              </a:ext>
+            </a:extLst>
+          </p:cNvPr>
+          <p:cNvCxnSpPr>
+            <a:cxnSpLocks/>
+          </p:cNvCxnSpPr>
+          <p:nvPr/>
+        </p:nvCxnSpPr>
+        <p:spPr>
+          <a:xfrm>
+            <a:off x="5306568" y="1545336"/>
+            <a:ext cx="0" cy="2249424"/>
+          </a:xfrm>
+          <a:prstGeom prst="line">
+            <a:avLst/>
+          </a:prstGeom>
+          <a:ln w="28575"/>
+        </p:spPr>
+        <p:style>
+          <a:lnRef idx="1">
+            <a:schemeClr val="accent1"/>
+          </a:lnRef>
+          <a:fillRef idx="0">
+            <a:schemeClr val="accent1"/>
+          </a:fillRef>
+          <a:effectRef idx="0">
+            <a:schemeClr val="accent1"/>
+          </a:effectRef>
+          <a:fontRef idx="minor">
+            <a:schemeClr val="tx1"/>
+          </a:fontRef>
+        </p:style>
+      </p:cxnSp>
     </p:spTree>
     <p:extLst>
       <p:ext uri="{BB962C8B-B14F-4D97-AF65-F5344CB8AC3E}">

</xml_diff>